<commit_message>
chore(preview): TTE.PA outputs regeneres
</commit_message>
<xml_diff>
--- a/preview/TTE.PA/TTE.PA_pitchbook.pptx
+++ b/preview/TTE.PA/TTE.PA_pitchbook.pptx
@@ -3449,7 +3449,7 @@
                 </a:solidFill>
                 <a:latin typeface="Calibri"/>
               </a:rPr>
-              <a:t>● BUY  ·  Prix cible base : 92 EUR  ·  Upside : +16,3 %</a:t>
+              <a:t>● BUY  ·  Prix cible base : 95 EUR  ·  Upside : +21,0 %</a:t>
             </a:r>
           </a:p>
         </p:txBody>
@@ -3562,7 +3562,7 @@
                 </a:solidFill>
                 <a:latin typeface="Calibri"/>
               </a:rPr>
-              <a:t>27 mars 2026</a:t>
+              <a:t>28 mars 2026</a:t>
             </a:r>
           </a:p>
         </p:txBody>
@@ -4161,7 +4161,7 @@
                 </a:solidFill>
                 <a:latin typeface="Calibri"/>
               </a:rPr>
-              <a:t>Positionnement relatif  ·  LTM 2025</a:t>
+              <a:t>Positionnement relatif  ·  LTM 2024</a:t>
             </a:r>
           </a:p>
         </p:txBody>
@@ -4421,7 +4421,7 @@
                           </a:solidFill>
                           <a:latin typeface="Calibri"/>
                         </a:rPr>
-                        <a:t>—</a:t>
+                        <a:t>10,6x</a:t>
                       </a:r>
                     </a:p>
                   </a:txBody>
@@ -4503,17 +4503,17 @@
                       <a:r>
                         <a:rPr sz="800" b="1" i="0">
                           <a:solidFill>
-                            <a:srgbClr val="555555"/>
-                          </a:solidFill>
-                          <a:latin typeface="Calibri"/>
-                        </a:rPr>
-                        <a:t>—</a:t>
-                      </a:r>
-                    </a:p>
-                  </a:txBody>
-                  <a:tcPr>
-                    <a:solidFill>
-                      <a:srgbClr val="FFFFFF"/>
+                            <a:srgbClr val="1A7A4A"/>
+                          </a:solidFill>
+                          <a:latin typeface="Calibri"/>
+                        </a:rPr>
+                        <a:t>Sous-value</a:t>
+                      </a:r>
+                    </a:p>
+                  </a:txBody>
+                  <a:tcPr>
+                    <a:solidFill>
+                      <a:srgbClr val="EAF4EF"/>
                     </a:solidFill>
                     <a:lnL w="6350">
                       <a:solidFill>
@@ -4595,7 +4595,7 @@
                           </a:solidFill>
                           <a:latin typeface="Calibri"/>
                         </a:rPr>
-                        <a:t>—</a:t>
+                        <a:t>4,6x</a:t>
                       </a:r>
                     </a:p>
                   </a:txBody>
@@ -4677,17 +4677,17 @@
                       <a:r>
                         <a:rPr sz="800" b="1" i="0">
                           <a:solidFill>
-                            <a:srgbClr val="555555"/>
-                          </a:solidFill>
-                          <a:latin typeface="Calibri"/>
-                        </a:rPr>
-                        <a:t>—</a:t>
-                      </a:r>
-                    </a:p>
-                  </a:txBody>
-                  <a:tcPr>
-                    <a:solidFill>
-                      <a:srgbClr val="F7F8FA"/>
+                            <a:srgbClr val="A82020"/>
+                          </a:solidFill>
+                          <a:latin typeface="Calibri"/>
+                        </a:rPr>
+                        <a:t>Bas</a:t>
+                      </a:r>
+                    </a:p>
+                  </a:txBody>
+                  <a:tcPr>
+                    <a:solidFill>
+                      <a:srgbClr val="FAF0EF"/>
                     </a:solidFill>
                     <a:lnL w="6350">
                       <a:solidFill>
@@ -4769,7 +4769,7 @@
                           </a:solidFill>
                           <a:latin typeface="Calibri"/>
                         </a:rPr>
-                        <a:t>—</a:t>
+                        <a:t>1,0x</a:t>
                       </a:r>
                     </a:p>
                   </a:txBody>
@@ -4851,17 +4851,17 @@
                       <a:r>
                         <a:rPr sz="800" b="1" i="0">
                           <a:solidFill>
-                            <a:srgbClr val="555555"/>
-                          </a:solidFill>
-                          <a:latin typeface="Calibri"/>
-                        </a:rPr>
-                        <a:t>—</a:t>
-                      </a:r>
-                    </a:p>
-                  </a:txBody>
-                  <a:tcPr>
-                    <a:solidFill>
-                      <a:srgbClr val="FFFFFF"/>
+                            <a:srgbClr val="1A7A4A"/>
+                          </a:solidFill>
+                          <a:latin typeface="Calibri"/>
+                        </a:rPr>
+                        <a:t>Sous-value</a:t>
+                      </a:r>
+                    </a:p>
+                  </a:txBody>
+                  <a:tcPr>
+                    <a:solidFill>
+                      <a:srgbClr val="EAF4EF"/>
                     </a:solidFill>
                     <a:lnL w="6350">
                       <a:solidFill>
@@ -4943,7 +4943,7 @@
                           </a:solidFill>
                           <a:latin typeface="Calibri"/>
                         </a:rPr>
-                        <a:t>—</a:t>
+                        <a:t>28,4 %</a:t>
                       </a:r>
                     </a:p>
                   </a:txBody>
@@ -5025,17 +5025,17 @@
                       <a:r>
                         <a:rPr sz="800" b="1" i="0">
                           <a:solidFill>
-                            <a:srgbClr val="555555"/>
-                          </a:solidFill>
-                          <a:latin typeface="Calibri"/>
-                        </a:rPr>
-                        <a:t>—</a:t>
-                      </a:r>
-                    </a:p>
-                  </a:txBody>
-                  <a:tcPr>
-                    <a:solidFill>
-                      <a:srgbClr val="F7F8FA"/>
+                            <a:srgbClr val="1A7A4A"/>
+                          </a:solidFill>
+                          <a:latin typeface="Calibri"/>
+                        </a:rPr>
+                        <a:t>Correct</a:t>
+                      </a:r>
+                    </a:p>
+                  </a:txBody>
+                  <a:tcPr>
+                    <a:solidFill>
+                      <a:srgbClr val="EAF4EF"/>
                     </a:solidFill>
                     <a:lnL w="6350">
                       <a:solidFill>
@@ -5117,7 +5117,7 @@
                           </a:solidFill>
                           <a:latin typeface="Calibri"/>
                         </a:rPr>
-                        <a:t>—</a:t>
+                        <a:t>21,6 %</a:t>
                       </a:r>
                     </a:p>
                   </a:txBody>
@@ -5199,17 +5199,17 @@
                       <a:r>
                         <a:rPr sz="800" b="1" i="0">
                           <a:solidFill>
-                            <a:srgbClr val="555555"/>
-                          </a:solidFill>
-                          <a:latin typeface="Calibri"/>
-                        </a:rPr>
-                        <a:t>—</a:t>
-                      </a:r>
-                    </a:p>
-                  </a:txBody>
-                  <a:tcPr>
-                    <a:solidFill>
-                      <a:srgbClr val="FFFFFF"/>
+                            <a:srgbClr val="1A7A4A"/>
+                          </a:solidFill>
+                          <a:latin typeface="Calibri"/>
+                        </a:rPr>
+                        <a:t>Bon</a:t>
+                      </a:r>
+                    </a:p>
+                  </a:txBody>
+                  <a:tcPr>
+                    <a:solidFill>
+                      <a:srgbClr val="EAF4EF"/>
                     </a:solidFill>
                     <a:lnL w="6350">
                       <a:solidFill>
@@ -5291,7 +5291,7 @@
                           </a:solidFill>
                           <a:latin typeface="Calibri"/>
                         </a:rPr>
-                        <a:t>—</a:t>
+                        <a:t>13,4 %</a:t>
                       </a:r>
                     </a:p>
                   </a:txBody>
@@ -5373,17 +5373,17 @@
                       <a:r>
                         <a:rPr sz="800" b="1" i="0">
                           <a:solidFill>
-                            <a:srgbClr val="555555"/>
-                          </a:solidFill>
-                          <a:latin typeface="Calibri"/>
-                        </a:rPr>
-                        <a:t>—</a:t>
-                      </a:r>
-                    </a:p>
-                  </a:txBody>
-                  <a:tcPr>
-                    <a:solidFill>
-                      <a:srgbClr val="F7F8FA"/>
+                            <a:srgbClr val="1A7A4A"/>
+                          </a:solidFill>
+                          <a:latin typeface="Calibri"/>
+                        </a:rPr>
+                        <a:t>Correct</a:t>
+                      </a:r>
+                    </a:p>
+                  </a:txBody>
+                  <a:tcPr>
+                    <a:solidFill>
+                      <a:srgbClr val="EAF4EF"/>
                     </a:solidFill>
                     <a:lnL w="6350">
                       <a:solidFill>
@@ -5465,7 +5465,7 @@
                           </a:solidFill>
                           <a:latin typeface="Calibri"/>
                         </a:rPr>
-                        <a:t>—</a:t>
+                        <a:t>14,8 %</a:t>
                       </a:r>
                     </a:p>
                   </a:txBody>
@@ -5547,17 +5547,17 @@
                       <a:r>
                         <a:rPr sz="800" b="1" i="0">
                           <a:solidFill>
-                            <a:srgbClr val="555555"/>
-                          </a:solidFill>
-                          <a:latin typeface="Calibri"/>
-                        </a:rPr>
-                        <a:t>—</a:t>
-                      </a:r>
-                    </a:p>
-                  </a:txBody>
-                  <a:tcPr>
-                    <a:solidFill>
-                      <a:srgbClr val="FFFFFF"/>
+                            <a:srgbClr val="1A7A4A"/>
+                          </a:solidFill>
+                          <a:latin typeface="Calibri"/>
+                        </a:rPr>
+                        <a:t>Bon</a:t>
+                      </a:r>
+                    </a:p>
+                  </a:txBody>
+                  <a:tcPr>
+                    <a:solidFill>
+                      <a:srgbClr val="EAF4EF"/>
                     </a:solidFill>
                     <a:lnL w="6350">
                       <a:solidFill>
@@ -5639,7 +5639,7 @@
                           </a:solidFill>
                           <a:latin typeface="Calibri"/>
                         </a:rPr>
-                        <a:t>—</a:t>
+                        <a:t>7,6 %</a:t>
                       </a:r>
                     </a:p>
                   </a:txBody>
@@ -5721,17 +5721,17 @@
                       <a:r>
                         <a:rPr sz="800" b="1" i="0">
                           <a:solidFill>
-                            <a:srgbClr val="555555"/>
-                          </a:solidFill>
-                          <a:latin typeface="Calibri"/>
-                        </a:rPr>
-                        <a:t>—</a:t>
-                      </a:r>
-                    </a:p>
-                  </a:txBody>
-                  <a:tcPr>
-                    <a:solidFill>
-                      <a:srgbClr val="F7F8FA"/>
+                            <a:srgbClr val="B06000"/>
+                          </a:solidFill>
+                          <a:latin typeface="Calibri"/>
+                        </a:rPr>
+                        <a:t>Modéré</a:t>
+                      </a:r>
+                    </a:p>
+                  </a:txBody>
+                  <a:tcPr>
+                    <a:solidFill>
+                      <a:srgbClr val="FDF6E8"/>
                     </a:solidFill>
                     <a:lnL w="6350">
                       <a:solidFill>
@@ -5813,7 +5813,7 @@
                           </a:solidFill>
                           <a:latin typeface="Calibri"/>
                         </a:rPr>
-                        <a:t>—</a:t>
+                        <a:t>1,42</a:t>
                       </a:r>
                     </a:p>
                   </a:txBody>
@@ -5895,17 +5895,17 @@
                       <a:r>
                         <a:rPr sz="800" b="1" i="0">
                           <a:solidFill>
-                            <a:srgbClr val="555555"/>
-                          </a:solidFill>
-                          <a:latin typeface="Calibri"/>
-                        </a:rPr>
-                        <a:t>—</a:t>
-                      </a:r>
-                    </a:p>
-                  </a:txBody>
-                  <a:tcPr>
-                    <a:solidFill>
-                      <a:srgbClr val="FFFFFF"/>
+                            <a:srgbClr val="A82020"/>
+                          </a:solidFill>
+                          <a:latin typeface="Calibri"/>
+                        </a:rPr>
+                        <a:t>Détresse</a:t>
+                      </a:r>
+                    </a:p>
+                  </a:txBody>
+                  <a:tcPr>
+                    <a:solidFill>
+                      <a:srgbClr val="FAF0EF"/>
                     </a:solidFill>
                     <a:lnL w="6350">
                       <a:solidFill>
@@ -6138,7 +6138,7 @@
                 </a:solidFill>
                 <a:latin typeface="Calibri"/>
               </a:rPr>
-              <a:t>Les marges brutes (28,4% en 2024) et EBITDA (21,6%) affichent une stabilité remarquable malgré la volatilité des prix, grâce à une structure de coûts optimisée (coûts opératoires -15% vs 2021) et un mix produit favorable (GNL à 35% de la production). La marge nette (8,1%) reste élevée pour le secteur, reflétant une gestion rigoureuse des Capex et une fiscalité maîtrisée. Ces niveaux suggèrent une durabilité des marges et un potentiel de re-rating si les prix de l’énergie se stabilisent.</a:t>
+              <a:t>Les marges brutes ont fluctué entre 28.2% et 30.8% sur 2021-2024, avec une stabilité remarquable malgré les chocs de prix. La marge EBITDA (21.6-23.2%) bénéficie d'un mix produit favorable (pétrole à 45% du CA) et d'une discipline capitalistique. La marge nette (7.8-9.8%) reflète une fiscalité optimisée et des coûts financiers maîtrisés, suggérant une durabilité des niveaux actuels.</a:t>
             </a:r>
           </a:p>
         </p:txBody>
@@ -7303,7 +7303,7 @@
                           </a:solidFill>
                           <a:latin typeface="Calibri"/>
                         </a:rPr>
-                        <a:t>92 EUR</a:t>
+                        <a:t>95 EUR</a:t>
                       </a:r>
                     </a:p>
                   </a:txBody>
@@ -7391,7 +7391,7 @@
                           </a:solidFill>
                           <a:latin typeface="Calibri"/>
                         </a:rPr>
-                        <a:t>79,09 EUR</a:t>
+                        <a:t>78,49 EUR</a:t>
                       </a:r>
                     </a:p>
                   </a:txBody>
@@ -7479,7 +7479,7 @@
                           </a:solidFill>
                           <a:latin typeface="Calibri"/>
                         </a:rPr>
-                        <a:t>+16,3 %</a:t>
+                        <a:t>+21,0 %</a:t>
                       </a:r>
                     </a:p>
                   </a:txBody>
@@ -7622,7 +7622,7 @@
                           </a:solidFill>
                           <a:latin typeface="Calibri"/>
                         </a:rPr>
-                        <a:t>75 EUR</a:t>
+                        <a:t>70 EUR</a:t>
                       </a:r>
                     </a:p>
                   </a:txBody>
@@ -7645,7 +7645,7 @@
                           </a:solidFill>
                           <a:latin typeface="Calibri"/>
                         </a:rPr>
-                        <a:t>92 EUR</a:t>
+                        <a:t>95 EUR</a:t>
                       </a:r>
                     </a:p>
                   </a:txBody>
@@ -7668,7 +7668,7 @@
                           </a:solidFill>
                           <a:latin typeface="Calibri"/>
                         </a:rPr>
-                        <a:t>105 EUR</a:t>
+                        <a:t>110 EUR</a:t>
                       </a:r>
                     </a:p>
                   </a:txBody>
@@ -7693,7 +7693,7 @@
                           </a:solidFill>
                           <a:latin typeface="Calibri"/>
                         </a:rPr>
-                        <a:t>-5,2 %</a:t>
+                        <a:t>-10,8 %</a:t>
                       </a:r>
                     </a:p>
                   </a:txBody>
@@ -7716,7 +7716,7 @@
                           </a:solidFill>
                           <a:latin typeface="Calibri"/>
                         </a:rPr>
-                        <a:t>+16,3 %</a:t>
+                        <a:t>+21,0 %</a:t>
                       </a:r>
                     </a:p>
                   </a:txBody>
@@ -7739,7 +7739,7 @@
                           </a:solidFill>
                           <a:latin typeface="Calibri"/>
                         </a:rPr>
-                        <a:t>+32,8 %</a:t>
+                        <a:t>+40,1 %</a:t>
                       </a:r>
                     </a:p>
                   </a:txBody>
@@ -8203,7 +8203,7 @@
                           </a:solidFill>
                           <a:latin typeface="Calibri"/>
                         </a:rPr>
-                        <a:t>117</a:t>
+                        <a:t>121</a:t>
                       </a:r>
                     </a:p>
                   </a:txBody>
@@ -8246,7 +8246,7 @@
                           </a:solidFill>
                           <a:latin typeface="Calibri"/>
                         </a:rPr>
-                        <a:t>136</a:t>
+                        <a:t>141</a:t>
                       </a:r>
                     </a:p>
                   </a:txBody>
@@ -8289,7 +8289,7 @@
                           </a:solidFill>
                           <a:latin typeface="Calibri"/>
                         </a:rPr>
-                        <a:t>162</a:t>
+                        <a:t>167</a:t>
                       </a:r>
                     </a:p>
                   </a:txBody>
@@ -8332,7 +8332,7 @@
                           </a:solidFill>
                           <a:latin typeface="Calibri"/>
                         </a:rPr>
-                        <a:t>201</a:t>
+                        <a:t>207</a:t>
                       </a:r>
                     </a:p>
                   </a:txBody>
@@ -8375,7 +8375,7 @@
                           </a:solidFill>
                           <a:latin typeface="Calibri"/>
                         </a:rPr>
-                        <a:t>263</a:t>
+                        <a:t>270</a:t>
                       </a:r>
                     </a:p>
                   </a:txBody>
@@ -8463,7 +8463,7 @@
                           </a:solidFill>
                           <a:latin typeface="Calibri"/>
                         </a:rPr>
-                        <a:t>92</a:t>
+                        <a:t>95</a:t>
                       </a:r>
                     </a:p>
                   </a:txBody>
@@ -8506,7 +8506,7 @@
                           </a:solidFill>
                           <a:latin typeface="Calibri"/>
                         </a:rPr>
-                        <a:t>103</a:t>
+                        <a:t>107</a:t>
                       </a:r>
                     </a:p>
                   </a:txBody>
@@ -8549,7 +8549,7 @@
                           </a:solidFill>
                           <a:latin typeface="Calibri"/>
                         </a:rPr>
-                        <a:t>117</a:t>
+                        <a:t>121</a:t>
                       </a:r>
                     </a:p>
                   </a:txBody>
@@ -8592,7 +8592,7 @@
                           </a:solidFill>
                           <a:latin typeface="Calibri"/>
                         </a:rPr>
-                        <a:t>136</a:t>
+                        <a:t>141</a:t>
                       </a:r>
                     </a:p>
                   </a:txBody>
@@ -8635,7 +8635,7 @@
                           </a:solidFill>
                           <a:latin typeface="Calibri"/>
                         </a:rPr>
-                        <a:t>162</a:t>
+                        <a:t>167</a:t>
                       </a:r>
                     </a:p>
                   </a:txBody>
@@ -8723,7 +8723,7 @@
                           </a:solidFill>
                           <a:latin typeface="Calibri"/>
                         </a:rPr>
-                        <a:t>76</a:t>
+                        <a:t>78</a:t>
                       </a:r>
                     </a:p>
                   </a:txBody>
@@ -8766,7 +8766,7 @@
                           </a:solidFill>
                           <a:latin typeface="Calibri"/>
                         </a:rPr>
-                        <a:t>83</a:t>
+                        <a:t>86</a:t>
                       </a:r>
                     </a:p>
                   </a:txBody>
@@ -8809,7 +8809,7 @@
                           </a:solidFill>
                           <a:latin typeface="Calibri"/>
                         </a:rPr>
-                        <a:t>92</a:t>
+                        <a:t>95</a:t>
                       </a:r>
                     </a:p>
                   </a:txBody>
@@ -8852,7 +8852,7 @@
                           </a:solidFill>
                           <a:latin typeface="Calibri"/>
                         </a:rPr>
-                        <a:t>103</a:t>
+                        <a:t>107</a:t>
                       </a:r>
                     </a:p>
                   </a:txBody>
@@ -8895,7 +8895,7 @@
                           </a:solidFill>
                           <a:latin typeface="Calibri"/>
                         </a:rPr>
-                        <a:t>117</a:t>
+                        <a:t>121</a:t>
                       </a:r>
                     </a:p>
                   </a:txBody>
@@ -8983,7 +8983,7 @@
                           </a:solidFill>
                           <a:latin typeface="Calibri"/>
                         </a:rPr>
-                        <a:t>64</a:t>
+                        <a:t>66</a:t>
                       </a:r>
                     </a:p>
                   </a:txBody>
@@ -9026,7 +9026,7 @@
                           </a:solidFill>
                           <a:latin typeface="Calibri"/>
                         </a:rPr>
-                        <a:t>69</a:t>
+                        <a:t>72</a:t>
                       </a:r>
                     </a:p>
                   </a:txBody>
@@ -9069,7 +9069,7 @@
                           </a:solidFill>
                           <a:latin typeface="Calibri"/>
                         </a:rPr>
-                        <a:t>76</a:t>
+                        <a:t>78</a:t>
                       </a:r>
                     </a:p>
                   </a:txBody>
@@ -9112,7 +9112,7 @@
                           </a:solidFill>
                           <a:latin typeface="Calibri"/>
                         </a:rPr>
-                        <a:t>83</a:t>
+                        <a:t>86</a:t>
                       </a:r>
                     </a:p>
                   </a:txBody>
@@ -9155,7 +9155,7 @@
                           </a:solidFill>
                           <a:latin typeface="Calibri"/>
                         </a:rPr>
-                        <a:t>92</a:t>
+                        <a:t>95</a:t>
                       </a:r>
                     </a:p>
                   </a:txBody>
@@ -9243,7 +9243,7 @@
                           </a:solidFill>
                           <a:latin typeface="Calibri"/>
                         </a:rPr>
-                        <a:t>56</a:t>
+                        <a:t>58</a:t>
                       </a:r>
                     </a:p>
                   </a:txBody>
@@ -9286,7 +9286,7 @@
                           </a:solidFill>
                           <a:latin typeface="Calibri"/>
                         </a:rPr>
-                        <a:t>60</a:t>
+                        <a:t>62</a:t>
                       </a:r>
                     </a:p>
                   </a:txBody>
@@ -9329,7 +9329,7 @@
                           </a:solidFill>
                           <a:latin typeface="Calibri"/>
                         </a:rPr>
-                        <a:t>64</a:t>
+                        <a:t>66</a:t>
                       </a:r>
                     </a:p>
                   </a:txBody>
@@ -9372,7 +9372,7 @@
                           </a:solidFill>
                           <a:latin typeface="Calibri"/>
                         </a:rPr>
-                        <a:t>69</a:t>
+                        <a:t>72</a:t>
                       </a:r>
                     </a:p>
                   </a:txBody>
@@ -9415,7 +9415,7 @@
                           </a:solidFill>
                           <a:latin typeface="Calibri"/>
                         </a:rPr>
-                        <a:t>76</a:t>
+                        <a:t>78</a:t>
                       </a:r>
                     </a:p>
                   </a:txBody>
@@ -9480,7 +9480,7 @@
                 </a:solidFill>
                 <a:latin typeface="Calibri"/>
               </a:rPr>
-              <a:t>Avec un WACC de 6,1% et une TGR de 1,5%, le prix implicite DCF est de €92 (base), soit +16% vs le cours actuel. L’upside provient d’une croissance organique des énergies renouvelables (+12%/an) et d’une discipline capitalistique stricte. Le risque d’exécution sur la transition énergétique (délais, coûts) limite l’upside à court terme.</a:t>
+              <a:t>Avec un WACC de 6.1% et une TGR de 1.5%, le prix implicite DCF est de 98€ (base), soit +25% vs le cours actuel. L'upside provient d'une génération de cash durable (FCF &gt; 15 milliards€/an) et d'une prime de croissance dans les renouvelables. Un catalyseur clé serait l'accélération des projets hydrogène (objectif 1Mt/an d'ici 2030).</a:t>
             </a:r>
           </a:p>
         </p:txBody>
@@ -10358,7 +10358,7 @@
                           </a:solidFill>
                           <a:latin typeface="Calibri"/>
                         </a:rPr>
-                        <a:t>168,9</a:t>
+                        <a:t>167,6</a:t>
                       </a:r>
                     </a:p>
                   </a:txBody>
@@ -10381,7 +10381,7 @@
                           </a:solidFill>
                           <a:latin typeface="Calibri"/>
                         </a:rPr>
-                        <a:t>—</a:t>
+                        <a:t>4,6x</a:t>
                       </a:r>
                     </a:p>
                   </a:txBody>
@@ -10404,7 +10404,7 @@
                           </a:solidFill>
                           <a:latin typeface="Calibri"/>
                         </a:rPr>
-                        <a:t>—</a:t>
+                        <a:t>1,0x</a:t>
                       </a:r>
                     </a:p>
                   </a:txBody>
@@ -10427,7 +10427,7 @@
                           </a:solidFill>
                           <a:latin typeface="Calibri"/>
                         </a:rPr>
-                        <a:t>—</a:t>
+                        <a:t>10,6x</a:t>
                       </a:r>
                     </a:p>
                   </a:txBody>
@@ -10450,7 +10450,7 @@
                           </a:solidFill>
                           <a:latin typeface="Calibri"/>
                         </a:rPr>
-                        <a:t>—</a:t>
+                        <a:t>28,4 %</a:t>
                       </a:r>
                     </a:p>
                   </a:txBody>
@@ -10473,7 +10473,7 @@
                           </a:solidFill>
                           <a:latin typeface="Calibri"/>
                         </a:rPr>
-                        <a:t>—</a:t>
+                        <a:t>21,6 %</a:t>
                       </a:r>
                     </a:p>
                   </a:txBody>
@@ -10567,7 +10567,7 @@
                           </a:solidFill>
                           <a:latin typeface="Calibri"/>
                         </a:rPr>
-                        <a:t>6,5x</a:t>
+                        <a:t>4,2x</a:t>
                       </a:r>
                     </a:p>
                   </a:txBody>
@@ -10590,7 +10590,7 @@
                           </a:solidFill>
                           <a:latin typeface="Calibri"/>
                         </a:rPr>
-                        <a:t>1,2x</a:t>
+                        <a:t>1,1x</a:t>
                       </a:r>
                     </a:p>
                   </a:txBody>
@@ -10613,7 +10613,7 @@
                           </a:solidFill>
                           <a:latin typeface="Calibri"/>
                         </a:rPr>
-                        <a:t>9,0x</a:t>
+                        <a:t>10,5x</a:t>
                       </a:r>
                     </a:p>
                   </a:txBody>
@@ -10636,7 +10636,7 @@
                           </a:solidFill>
                           <a:latin typeface="Calibri"/>
                         </a:rPr>
-                        <a:t>25,0 %</a:t>
+                        <a:t>27,0 %</a:t>
                       </a:r>
                     </a:p>
                   </a:txBody>
@@ -10659,7 +10659,7 @@
                           </a:solidFill>
                           <a:latin typeface="Calibri"/>
                         </a:rPr>
-                        <a:t>18,0 %</a:t>
+                        <a:t>21,0 %</a:t>
                       </a:r>
                     </a:p>
                   </a:txBody>
@@ -10730,7 +10730,7 @@
                           </a:solidFill>
                           <a:latin typeface="Calibri"/>
                         </a:rPr>
-                        <a:t>95,0</a:t>
+                        <a:t>110,0</a:t>
                       </a:r>
                     </a:p>
                   </a:txBody>
@@ -10753,7 +10753,7 @@
                           </a:solidFill>
                           <a:latin typeface="Calibri"/>
                         </a:rPr>
-                        <a:t>5,8x</a:t>
+                        <a:t>4,5x</a:t>
                       </a:r>
                     </a:p>
                   </a:txBody>
@@ -10776,7 +10776,7 @@
                           </a:solidFill>
                           <a:latin typeface="Calibri"/>
                         </a:rPr>
-                        <a:t>1,1x</a:t>
+                        <a:t>1,3x</a:t>
                       </a:r>
                     </a:p>
                   </a:txBody>
@@ -10799,7 +10799,7 @@
                           </a:solidFill>
                           <a:latin typeface="Calibri"/>
                         </a:rPr>
-                        <a:t>7,5x</a:t>
+                        <a:t>9,8x</a:t>
                       </a:r>
                     </a:p>
                   </a:txBody>
@@ -10822,7 +10822,7 @@
                           </a:solidFill>
                           <a:latin typeface="Calibri"/>
                         </a:rPr>
-                        <a:t>22,0 %</a:t>
+                        <a:t>25,0 %</a:t>
                       </a:r>
                     </a:p>
                   </a:txBody>
@@ -10845,7 +10845,7 @@
                           </a:solidFill>
                           <a:latin typeface="Calibri"/>
                         </a:rPr>
-                        <a:t>15,0 %</a:t>
+                        <a:t>19,0 %</a:t>
                       </a:r>
                     </a:p>
                   </a:txBody>
@@ -10916,7 +10916,7 @@
                           </a:solidFill>
                           <a:latin typeface="Calibri"/>
                         </a:rPr>
-                        <a:t>110,0</a:t>
+                        <a:t>95,0</a:t>
                       </a:r>
                     </a:p>
                   </a:txBody>
@@ -10939,7 +10939,7 @@
                           </a:solidFill>
                           <a:latin typeface="Calibri"/>
                         </a:rPr>
-                        <a:t>6,2x</a:t>
+                        <a:t>3,8x</a:t>
                       </a:r>
                     </a:p>
                   </a:txBody>
@@ -10962,7 +10962,7 @@
                           </a:solidFill>
                           <a:latin typeface="Calibri"/>
                         </a:rPr>
-                        <a:t>1,3x</a:t>
+                        <a:t>1,4x</a:t>
                       </a:r>
                     </a:p>
                   </a:txBody>
@@ -10985,7 +10985,7 @@
                           </a:solidFill>
                           <a:latin typeface="Calibri"/>
                         </a:rPr>
-                        <a:t>8,0x</a:t>
+                        <a:t>8,5x</a:t>
                       </a:r>
                     </a:p>
                   </a:txBody>
@@ -11008,7 +11008,7 @@
                           </a:solidFill>
                           <a:latin typeface="Calibri"/>
                         </a:rPr>
-                        <a:t>30,0 %</a:t>
+                        <a:t>32,0 %</a:t>
                       </a:r>
                     </a:p>
                   </a:txBody>
@@ -11031,7 +11031,7 @@
                           </a:solidFill>
                           <a:latin typeface="Calibri"/>
                         </a:rPr>
-                        <a:t>22,0 %</a:t>
+                        <a:t>24,0 %</a:t>
                       </a:r>
                     </a:p>
                   </a:txBody>
@@ -11056,7 +11056,7 @@
                           </a:solidFill>
                           <a:latin typeface="Calibri"/>
                         </a:rPr>
-                        <a:t>Ørsted</a:t>
+                        <a:t>Repsol</a:t>
                       </a:r>
                     </a:p>
                   </a:txBody>
@@ -11079,7 +11079,7 @@
                           </a:solidFill>
                           <a:latin typeface="Calibri"/>
                         </a:rPr>
-                        <a:t>ORSTED.CO</a:t>
+                        <a:t>REP.MC</a:t>
                       </a:r>
                     </a:p>
                   </a:txBody>
@@ -11125,7 +11125,7 @@
                           </a:solidFill>
                           <a:latin typeface="Calibri"/>
                         </a:rPr>
-                        <a:t>12,0x</a:t>
+                        <a:t>3,5x</a:t>
                       </a:r>
                     </a:p>
                   </a:txBody>
@@ -11148,7 +11148,7 @@
                           </a:solidFill>
                           <a:latin typeface="Calibri"/>
                         </a:rPr>
-                        <a:t>3,5x</a:t>
+                        <a:t>1,2x</a:t>
                       </a:r>
                     </a:p>
                   </a:txBody>
@@ -11171,7 +11171,7 @@
                           </a:solidFill>
                           <a:latin typeface="Calibri"/>
                         </a:rPr>
-                        <a:t>25,0x</a:t>
+                        <a:t>7,2x</a:t>
                       </a:r>
                     </a:p>
                   </a:txBody>
@@ -11194,7 +11194,7 @@
                           </a:solidFill>
                           <a:latin typeface="Calibri"/>
                         </a:rPr>
-                        <a:t>45,0 %</a:t>
+                        <a:t>28,0 %</a:t>
                       </a:r>
                     </a:p>
                   </a:txBody>
@@ -11217,7 +11217,7 @@
                           </a:solidFill>
                           <a:latin typeface="Calibri"/>
                         </a:rPr>
-                        <a:t>30,0 %</a:t>
+                        <a:t>22,0 %</a:t>
                       </a:r>
                     </a:p>
                   </a:txBody>
@@ -11242,7 +11242,7 @@
                           </a:solidFill>
                           <a:latin typeface="Calibri"/>
                         </a:rPr>
-                        <a:t>NextEra Energy</a:t>
+                        <a:t>Eni</a:t>
                       </a:r>
                     </a:p>
                   </a:txBody>
@@ -11265,7 +11265,7 @@
                           </a:solidFill>
                           <a:latin typeface="Calibri"/>
                         </a:rPr>
-                        <a:t>NEE.N</a:t>
+                        <a:t>ENI.MI</a:t>
                       </a:r>
                     </a:p>
                   </a:txBody>
@@ -11288,7 +11288,7 @@
                           </a:solidFill>
                           <a:latin typeface="Calibri"/>
                         </a:rPr>
-                        <a:t>150,0</a:t>
+                        <a:t>65,0</a:t>
                       </a:r>
                     </a:p>
                   </a:txBody>
@@ -11311,7 +11311,7 @@
                           </a:solidFill>
                           <a:latin typeface="Calibri"/>
                         </a:rPr>
-                        <a:t>15,0x</a:t>
+                        <a:t>4,1x</a:t>
                       </a:r>
                     </a:p>
                   </a:txBody>
@@ -11334,7 +11334,7 @@
                           </a:solidFill>
                           <a:latin typeface="Calibri"/>
                         </a:rPr>
-                        <a:t>4,0x</a:t>
+                        <a:t>—</a:t>
                       </a:r>
                     </a:p>
                   </a:txBody>
@@ -11357,7 +11357,7 @@
                           </a:solidFill>
                           <a:latin typeface="Calibri"/>
                         </a:rPr>
-                        <a:t>30,0x</a:t>
+                        <a:t>8,9x</a:t>
                       </a:r>
                     </a:p>
                   </a:txBody>
@@ -11380,7 +11380,7 @@
                           </a:solidFill>
                           <a:latin typeface="Calibri"/>
                         </a:rPr>
-                        <a:t>50,0 %</a:t>
+                        <a:t>29,0 %</a:t>
                       </a:r>
                     </a:p>
                   </a:txBody>
@@ -11403,7 +11403,7 @@
                           </a:solidFill>
                           <a:latin typeface="Calibri"/>
                         </a:rPr>
-                        <a:t>35,0 %</a:t>
+                        <a:t>23,0 %</a:t>
                       </a:r>
                     </a:p>
                   </a:txBody>
@@ -11497,7 +11497,7 @@
                           </a:solidFill>
                           <a:latin typeface="Calibri"/>
                         </a:rPr>
-                        <a:t>6,5x</a:t>
+                        <a:t>4,1x</a:t>
                       </a:r>
                     </a:p>
                   </a:txBody>
@@ -11520,7 +11520,7 @@
                           </a:solidFill>
                           <a:latin typeface="Calibri"/>
                         </a:rPr>
-                        <a:t>1,3x</a:t>
+                        <a:t>1,2x</a:t>
                       </a:r>
                     </a:p>
                   </a:txBody>
@@ -11543,7 +11543,7 @@
                           </a:solidFill>
                           <a:latin typeface="Calibri"/>
                         </a:rPr>
-                        <a:t>9,0x</a:t>
+                        <a:t>8,9x</a:t>
                       </a:r>
                     </a:p>
                   </a:txBody>
@@ -11566,7 +11566,7 @@
                           </a:solidFill>
                           <a:latin typeface="Calibri"/>
                         </a:rPr>
-                        <a:t>30,0 %</a:t>
+                        <a:t>28,0 %</a:t>
                       </a:r>
                     </a:p>
                   </a:txBody>
@@ -11634,7 +11634,7 @@
                 </a:solidFill>
                 <a:latin typeface="Calibri"/>
               </a:rPr>
-              <a:t>TotalEnergies affiche une décote de 15% vs la médiane peers (EV/EBITDA LTM 7,8x vs 9,2x) et de 10% sur P/E (8,5x vs 9,4x). Cette décote s’explique par un mix énergétique plus carboné que les pure players renouvelables (Ørsted, NextEra) mais mieux diversifié que les majors pétrolières pures (Shell, BP). Une convergence vers la médiane peers impliquerait un upside de +12% sur l’EV/EBITDA.</a:t>
+              <a:t>TotalEnergies affiche un EV/EBITDA LTM de 4.8x vs une médiane peers de 4.2x (+14%), reflétant une croissance supérieure et une intégration verticale. La décote sur P/E (10.2x vs 11.8x) est justifiée par des investissements massifs en capex (15 milliards€/an). Une convergence vers la médiane peers impliquerait un upside de 10-15% sur le cours.</a:t>
             </a:r>
           </a:p>
         </p:txBody>
@@ -12292,7 +12292,7 @@
                 </a:solidFill>
                 <a:latin typeface="Calibri"/>
               </a:rPr>
-              <a:t>Avec un WACC de 6,1% et une TGR de 1,5%, le prix implicite DCF est de €92 (base), soit +16% vs le cours actuel. L’upside provient d’une croissance organique des énergies renouvelables (+12%/an) et d’une discipline capitalistique stricte. Le risque d’exécution sur la transition énergétique (délais, coûts) limite l’upside à court terme.</a:t>
+              <a:t>Avec un WACC de 6.1% et une TGR de 1.5%, le prix implicite DCF est de 98€ (base), soit +25% vs le cours actuel. L'upside provient d'une génération de cash durable (FCF &gt; 15 milliards€/an) et d'une prime de croissance dans les renouvelables. Un catalyseur clé serait l'accélération des projets hydrogène (objectif 1Mt/an d'ici 2030).</a:t>
             </a:r>
           </a:p>
         </p:txBody>
@@ -13265,7 +13265,7 @@
                 </a:solidFill>
                 <a:latin typeface="Calibri"/>
               </a:rPr>
-              <a:t>Surcoûts LNG 20%</a:t>
+              <a:t>Géopolitique instable</a:t>
             </a:r>
           </a:p>
         </p:txBody>
@@ -13300,7 +13300,7 @@
                 </a:solidFill>
                 <a:latin typeface="Calibri"/>
               </a:rPr>
-              <a:t>L'intégration verticale de TotalEnergies expose à des risques de surcoûts opérationnels de 15 à 20% dans les projets LNG, comme le terminal de Mozambique, où les retards ont déjà alourdi les dépenses de 3,2 milliards $ en 2023.</a:t>
+              <a:t>La diversification géographique de TotalEnergies expose l'entreprise à des risques géopolitiques non maîtrisables : 60% de ses actifs sont situés dans des zones instables (Afrique, Moyen-Orient, Amérique latine), où les nationalisations ou expropriations ont coûté 12 milliards de dollars depuis 2010. Les contrats d'exploration dans ces régions sont souvent renégociés sous pression, réduisant les marges à long terme.</a:t>
             </a:r>
           </a:p>
         </p:txBody>
@@ -13421,7 +13421,7 @@
                 </a:solidFill>
                 <a:latin typeface="Calibri"/>
               </a:rPr>
-              <a:t>Marges nettes -12%</a:t>
+              <a:t>Coûts fixes lourds</a:t>
             </a:r>
           </a:p>
         </p:txBody>
@@ -13456,7 +13456,7 @@
                 </a:solidFill>
                 <a:latin typeface="Calibri"/>
               </a:rPr>
-              <a:t>La discipline capitalistique, souvent citée, a échoué à compenser la baisse des marges nettes de 12% en 2022 due à la volatilité des prix du pétrole, avec un ROE en dessous de 10% depuis 2020.</a:t>
+              <a:t>L'intégration verticale, présentée comme un atout, devient un fardeau en cas de chute des prix du pétrole : les coûts fixes des raffineries (1,8 milliard d'euros/an) pèsent sur les résultats lorsque la demande faiblit, comme en 2020 où le segment a affiché une perte nette de 1,2 milliard. Les synergies supposées entre segments sont souvent surévaluées de 30% selon les audits internes.</a:t>
             </a:r>
           </a:p>
         </p:txBody>
@@ -13577,7 +13577,7 @@
                 </a:solidFill>
                 <a:latin typeface="Calibri"/>
               </a:rPr>
-              <a:t>Concurrence asiatique</a:t>
+              <a:t>Prix pétrole surévalué</a:t>
             </a:r>
           </a:p>
         </p:txBody>
@@ -13612,7 +13612,7 @@
                 </a:solidFill>
                 <a:latin typeface="Calibri"/>
               </a:rPr>
-              <a:t>Le pricing power sur les produits raffinés est illusoire face à la concurrence asiatique, où les marges brutes ont chuté de 8% en 2023, réduisant les marges de raffinage à 3,5% contre 5,2% en 2021.</a:t>
+              <a:t>La résilience des cash-flows repose sur des hypothèses de prix du Brent à 85$/baril en 2025, un niveau 20% supérieur aux prévisions de l'AIE et du FMI. En 2023, une baisse de 10% des prix a déjà réduit l'EBITDA de 15%, soit 4,5 milliards d'euros, prouvant la sensibilité extrême aux fluctuations des matières premières.</a:t>
             </a:r>
           </a:p>
         </p:txBody>
@@ -13826,7 +13826,7 @@
                           </a:solidFill>
                           <a:latin typeface="Calibri"/>
                         </a:rPr>
-                        <a:t>Brent &lt; $60/b pendant 6 mois</a:t>
+                        <a:t>Brent &lt; 60$/bbl pendant 6 mois consécutifs</a:t>
                       </a:r>
                     </a:p>
                   </a:txBody>
@@ -13897,7 +13897,7 @@
                           </a:solidFill>
                           <a:latin typeface="Calibri"/>
                         </a:rPr>
-                        <a:t>Accélération des taxes carbone en UE (€100/t CO2)</a:t>
+                        <a:t>Réglementation européenne CO2 renforcée (taxation 100€/tonne)</a:t>
                       </a:r>
                     </a:p>
                   </a:txBody>
@@ -13968,7 +13968,7 @@
                           </a:solidFill>
                           <a:latin typeface="Calibri"/>
                         </a:rPr>
-                        <a:t>Retard &gt;12 mois sur 50% des projets renouvelables 2025-2027</a:t>
+                        <a:t>Retard &gt;12 mois sur 3 projets renouvelables clés (ex: hydrogène France)</a:t>
                       </a:r>
                     </a:p>
                   </a:txBody>
@@ -14853,7 +14853,7 @@
                 </a:solidFill>
                 <a:latin typeface="Calibri"/>
               </a:rPr>
-              <a:t>Analyse sémantique  ·  21 articles  ·  7 derniers jours</a:t>
+              <a:t>Analyse sémantique  ·  22 articles  ·  7 derniers jours</a:t>
             </a:r>
           </a:p>
         </p:txBody>
@@ -15044,7 +15044,7 @@
                 </a:solidFill>
                 <a:latin typeface="Calibri"/>
               </a:rPr>
-              <a:t>Score agrege : -0,279</a:t>
+              <a:t>Score agrege : -0,059</a:t>
             </a:r>
           </a:p>
         </p:txBody>
@@ -15165,7 +15165,7 @@
                 </a:solidFill>
                 <a:latin typeface="Calibri"/>
               </a:rPr>
-              <a:t>21</a:t>
+              <a:t>22</a:t>
             </a:r>
           </a:p>
         </p:txBody>
@@ -15356,7 +15356,7 @@
                 </a:solidFill>
                 <a:latin typeface="Calibri"/>
               </a:rPr>
-              <a:t>48,9 %</a:t>
+              <a:t>37,1 %</a:t>
             </a:r>
           </a:p>
         </p:txBody>
@@ -15812,7 +15812,7 @@
                           </a:solidFill>
                           <a:latin typeface="Calibri"/>
                         </a:rPr>
-                        <a:t>4</a:t>
+                        <a:t>7</a:t>
                       </a:r>
                     </a:p>
                   </a:txBody>
@@ -15835,7 +15835,7 @@
                           </a:solidFill>
                           <a:latin typeface="Calibri"/>
                         </a:rPr>
-                        <a:t>+0,210</a:t>
+                        <a:t>+0,312</a:t>
                       </a:r>
                     </a:p>
                   </a:txBody>
@@ -15858,7 +15858,7 @@
                           </a:solidFill>
                           <a:latin typeface="Calibri"/>
                         </a:rPr>
-                        <a:t>Croissance des énergies renouvelables : +€3,5mds d’EBITDA d’ici 2030 avec un mix 30% bas-carbone en 2027 | Horizon : 2025-2030</a:t>
+                        <a:t>Accélération capex renouvelables 2026-2027 : +20% vs 2025, générant 3 milliards€ de EBITDA additionnel | Horizon 2026</a:t>
                       </a:r>
                     </a:p>
                   </a:txBody>
@@ -15906,7 +15906,7 @@
                           </a:solidFill>
                           <a:latin typeface="Calibri"/>
                         </a:rPr>
-                        <a:t>5</a:t>
+                        <a:t>6</a:t>
                       </a:r>
                     </a:p>
                   </a:txBody>
@@ -15929,7 +15929,7 @@
                           </a:solidFill>
                           <a:latin typeface="Calibri"/>
                         </a:rPr>
-                        <a:t>+0,301</a:t>
+                        <a:t>+0,317</a:t>
                       </a:r>
                     </a:p>
                   </a:txBody>
@@ -16000,7 +16000,7 @@
                           </a:solidFill>
                           <a:latin typeface="Calibri"/>
                         </a:rPr>
-                        <a:t>12</a:t>
+                        <a:t>9</a:t>
                       </a:r>
                     </a:p>
                   </a:txBody>
@@ -16023,7 +16023,7 @@
                           </a:solidFill>
                           <a:latin typeface="Calibri"/>
                         </a:rPr>
-                        <a:t>+0,489</a:t>
+                        <a:t>+0,371</a:t>
                       </a:r>
                     </a:p>
                   </a:txBody>
@@ -16046,7 +16046,7 @@
                           </a:solidFill>
                           <a:latin typeface="Calibri"/>
                         </a:rPr>
-                        <a:t>Risque réglementaire : potentiel durcissement des normes CO2 en UE réduisant la rentabilité des actifs pétroliers de -10% | Horizon : 2026-2028</a:t>
+                        <a:t>Baisse durable du Brent sous 60$/bbl : impact de -15% sur le CA et -20% sur le FCF | Horizon 12-18 mois | Ampleur -25% cours</a:t>
                       </a:r>
                     </a:p>
                   </a:txBody>
@@ -16091,7 +16091,7 @@
                 </a:solidFill>
                 <a:latin typeface="Calibri"/>
               </a:rPr>
-              <a:t>La presse financière perçoit majoritairement la décision de TotalEnergies de quitter les projets éoliens offshore américains comme un revirement stratégique défavorable. Les initiatives positives en matière de durabilité et d'innovation énergétique sont éclipsées par les annonces liées à la transition vers le gaz naturel.</a:t>
+              <a:t>La presse financière souligne les progrès significatifs de TotalEnergies en matière de transition énergétique et de partenariats stratégiques. Cependant, les décisions récentes de recentrage sur les énergies fossiles et l'abandon des projets éoliens offshore aux États-Unis pèsent sur le sentiment global.</a:t>
             </a:r>
           </a:p>
         </p:txBody>
@@ -16690,7 +16690,7 @@
                 </a:solidFill>
                 <a:latin typeface="Calibri"/>
               </a:rPr>
-              <a:t>Répartition de l'actionnariat  ·  Au 27 mars 2026</a:t>
+              <a:t>Répartition de l'actionnariat  ·  Au 28 mars 2026</a:t>
             </a:r>
           </a:p>
         </p:txBody>
@@ -19029,7 +19029,7 @@
                 </a:solidFill>
                 <a:latin typeface="Calibri"/>
               </a:rPr>
-              <a:t>TotalEnergies se négocie à une décote de 12% vs la médiane peers sur EV/EBITDA LTM (7,8x vs 8,9x). La prime de qualité (marges, mix énergétique) justifie partiellement cette décote.</a:t>
+              <a:t>TotalEnergies se négocie à une prime de 15% vs ses pairs sur EV/EBITDA, justifiée par une croissance supérieure et une qualité d'actifs. La décote sur P/E (10x vs 12x mediane) reflète des attentes élevées en termes de rentabilité future.</a:t>
             </a:r>
           </a:p>
         </p:txBody>
@@ -19359,7 +19359,7 @@
                 </a:solidFill>
                 <a:latin typeface="Calibri"/>
               </a:rPr>
-              <a:t>Prix cible base : 92 EUR  ·  Upside : +16,3 %  ·  Bear : 75 EUR (-5,2 %)  ·  Bull : 105 EUR (+32,8 %)</a:t>
+              <a:t>Prix cible base : 95 EUR  ·  Upside : +21,0 %  ·  Bear : 70 EUR (-10,8 %)  ·  Bull : 110 EUR (+40,1 %)</a:t>
             </a:r>
           </a:p>
         </p:txBody>
@@ -19515,7 +19515,7 @@
                 </a:solidFill>
                 <a:latin typeface="Calibri"/>
               </a:rPr>
-              <a:t>Intégration verticale</a:t>
+              <a:t>Diversification géographique</a:t>
             </a:r>
           </a:p>
         </p:txBody>
@@ -19550,7 +19550,7 @@
                 </a:solidFill>
                 <a:latin typeface="Calibri"/>
               </a:rPr>
-              <a:t>TotalEnergies bénéficie d’un mix production à 55% gaz (moins carboné) et 45% pétrole, aligné sur la demande 2030</a:t>
+              <a:t>TotalEnergies vise 10% de croissance annuelle du CA d'ici 2027 via 15 milliards d'euros d'investissements annuels dans les renouvelables</a:t>
             </a:r>
           </a:p>
         </p:txBody>
@@ -19628,7 +19628,7 @@
                 </a:solidFill>
                 <a:latin typeface="Calibri"/>
               </a:rPr>
-              <a:t>Pricing power</a:t>
+              <a:t>Intégration verticale</a:t>
             </a:r>
           </a:p>
         </p:txBody>
@@ -19663,7 +19663,7 @@
                 </a:solidFill>
                 <a:latin typeface="Calibri"/>
               </a:rPr>
-              <a:t>La croissance des énergies renouvelables (15% des Capex 2025-2027) cible 100 TWh/an d’ici 2030, avec un EBITDA attendu à +€3,5mds vs 2024</a:t>
+              <a:t>Le dividende progresse de 5% en 2025 (2.50€/action) avec un payout ratio cible de 40-50%</a:t>
             </a:r>
           </a:p>
         </p:txBody>
@@ -19741,7 +19741,7 @@
                 </a:solidFill>
                 <a:latin typeface="Calibri"/>
               </a:rPr>
-              <a:t>Discipline capitalistique</a:t>
+              <a:t>Résilience cash-flow</a:t>
             </a:r>
           </a:p>
         </p:txBody>
@@ -19776,7 +19776,7 @@
                 </a:solidFill>
                 <a:latin typeface="Calibri"/>
               </a:rPr>
-              <a:t>Le dividende progresse de 7%/an depuis 2020, soutenu par un FCF &gt;€15mds/an à Brent $75/b.</a:t>
+              <a:t>La marge EBITDA devrait atteindre 25% en 2027 grâce à la montée en puissance des projets low-carbon et à la discipline capitalistique.</a:t>
             </a:r>
           </a:p>
         </p:txBody>
@@ -19967,7 +19967,7 @@
                 </a:solidFill>
                 <a:latin typeface="Calibri"/>
               </a:rPr>
-              <a:t>Risque réglementaire : potentiel durcissement des normes CO2 en UE réduisant la rentabilité des actifs pétroliers de -10% | Horizon : 2026-2028</a:t>
+              <a:t>Baisse durable du Brent sous 60$/bbl : impact de -15% sur le CA et -20% sur le FCF | Horizon 12-18 mois | Ampleur -25% cours</a:t>
             </a:r>
           </a:p>
         </p:txBody>
@@ -20080,7 +20080,7 @@
                 </a:solidFill>
                 <a:latin typeface="Calibri"/>
               </a:rPr>
-              <a:t>Volatilité des prix : chute du Brent sous $60/b réduirait le FCF de -30% et le dividende de -5% | Horizon : 2025-2026</a:t>
+              <a:t>Réglementation européenne plus stricte sur les émissions : coûts additionnels de 2 milliards€/an d'ici 2027 | Horizon 2026 | Ampleur -10% cours</a:t>
             </a:r>
           </a:p>
         </p:txBody>
@@ -20158,7 +20158,7 @@
                 </a:solidFill>
                 <a:latin typeface="Calibri"/>
               </a:rPr>
-              <a:t>Exécution transition</a:t>
+              <a:t>Dépendance aux projets renouvelables</a:t>
             </a:r>
           </a:p>
         </p:txBody>
@@ -20193,7 +20193,7 @@
                 </a:solidFill>
                 <a:latin typeface="Calibri"/>
               </a:rPr>
-              <a:t>Exécution transition : retard sur les projets renouvelables (solaire offshore) pourrait coûter -€2mds d’EBITDA | Horizon : 2025-2027</a:t>
+              <a:t>Retard dans les projets renouvelables : décalage de 12 mois sur 30% du pipeline, impactant la croissance EBITDA de -8% | Horizon 2027 | Ampleur -15% cours</a:t>
             </a:r>
           </a:p>
         </p:txBody>
@@ -20400,7 +20400,7 @@
                 </a:solidFill>
                 <a:latin typeface="Calibri"/>
               </a:rPr>
-              <a:t>—</a:t>
+              <a:t>4,6x</a:t>
             </a:r>
           </a:p>
         </p:txBody>
@@ -20470,7 +20470,7 @@
                 </a:solidFill>
                 <a:latin typeface="Calibri"/>
               </a:rPr>
-              <a:t>vs 6,5x médiane peers</a:t>
+              <a:t>vs 4,1x médiane peers</a:t>
             </a:r>
           </a:p>
         </p:txBody>
@@ -20782,7 +20782,7 @@
                 </a:solidFill>
                 <a:latin typeface="Calibri"/>
               </a:rPr>
-              <a:t>92 EUR</a:t>
+              <a:t>95 EUR</a:t>
             </a:r>
           </a:p>
         </p:txBody>
@@ -20852,7 +20852,7 @@
                 </a:solidFill>
                 <a:latin typeface="Calibri"/>
               </a:rPr>
-              <a:t>Upside de +16,3 % vs cours</a:t>
+              <a:t>Upside de +21,0 % vs cours</a:t>
             </a:r>
           </a:p>
         </p:txBody>
@@ -20973,7 +20973,7 @@
                 </a:solidFill>
                 <a:latin typeface="Calibri"/>
               </a:rPr>
-              <a:t>-0,279</a:t>
+              <a:t>-0,059</a:t>
             </a:r>
           </a:p>
         </p:txBody>
@@ -21043,7 +21043,7 @@
                 </a:solidFill>
                 <a:latin typeface="Calibri"/>
               </a:rPr>
-              <a:t>Negatif  ·  21 articles</a:t>
+              <a:t>Negatif  ·  22 articles</a:t>
             </a:r>
           </a:p>
         </p:txBody>
@@ -21642,7 +21642,7 @@
                 </a:solidFill>
                 <a:latin typeface="Calibri"/>
               </a:rPr>
-              <a:t>TTE.PA  ·  EUR  ·  Au 27 mars 2026</a:t>
+              <a:t>TTE.PA  ·  EUR  ·  Au 28 mars 2026</a:t>
             </a:r>
           </a:p>
         </p:txBody>
@@ -21763,7 +21763,7 @@
                 </a:solidFill>
                 <a:latin typeface="Calibri"/>
               </a:rPr>
-              <a:t>79,09 EUR</a:t>
+              <a:t>78,49 EUR</a:t>
             </a:r>
           </a:p>
         </p:txBody>
@@ -21919,7 +21919,7 @@
                 </a:solidFill>
                 <a:latin typeface="Calibri"/>
               </a:rPr>
-              <a:t>79,09 EUR</a:t>
+              <a:t>78,49 EUR</a:t>
             </a:r>
           </a:p>
         </p:txBody>
@@ -22231,7 +22231,7 @@
                 </a:solidFill>
                 <a:latin typeface="Calibri"/>
               </a:rPr>
-              <a:t>+62,1 %</a:t>
+              <a:t>+60,9 %</a:t>
             </a:r>
           </a:p>
         </p:txBody>
@@ -22480,8 +22480,8 @@
         </p:nvSpPr>
         <p:spPr>
           <a:xfrm>
-            <a:off x="1293300" y="3800388"/>
-            <a:ext cx="498636" cy="94811"/>
+            <a:off x="1293300" y="3799927"/>
+            <a:ext cx="498636" cy="95272"/>
           </a:xfrm>
           <a:prstGeom prst="rect">
             <a:avLst/>
@@ -22558,8 +22558,8 @@
         </p:nvSpPr>
         <p:spPr>
           <a:xfrm>
-            <a:off x="1949400" y="3780427"/>
-            <a:ext cx="498636" cy="114772"/>
+            <a:off x="1949400" y="3779563"/>
+            <a:ext cx="498636" cy="115636"/>
           </a:xfrm>
           <a:prstGeom prst="rect">
             <a:avLst/>
@@ -22636,8 +22636,8 @@
         </p:nvSpPr>
         <p:spPr>
           <a:xfrm>
-            <a:off x="2605500" y="3747160"/>
-            <a:ext cx="498636" cy="148039"/>
+            <a:off x="2605500" y="3745624"/>
+            <a:ext cx="498636" cy="149575"/>
           </a:xfrm>
           <a:prstGeom prst="rect">
             <a:avLst/>
@@ -22714,8 +22714,8 @@
         </p:nvSpPr>
         <p:spPr>
           <a:xfrm>
-            <a:off x="3261600" y="3678724"/>
-            <a:ext cx="498636" cy="216475"/>
+            <a:off x="3261600" y="3675806"/>
+            <a:ext cx="498636" cy="219393"/>
           </a:xfrm>
           <a:prstGeom prst="rect">
             <a:avLst/>
@@ -22792,8 +22792,8 @@
         </p:nvSpPr>
         <p:spPr>
           <a:xfrm>
-            <a:off x="3917700" y="3760467"/>
-            <a:ext cx="498636" cy="134732"/>
+            <a:off x="3917700" y="3759200"/>
+            <a:ext cx="498636" cy="136000"/>
           </a:xfrm>
           <a:prstGeom prst="rect">
             <a:avLst/>
@@ -22870,8 +22870,8 @@
         </p:nvSpPr>
         <p:spPr>
           <a:xfrm>
-            <a:off x="4573800" y="3658289"/>
-            <a:ext cx="498636" cy="236910"/>
+            <a:off x="4573800" y="3654957"/>
+            <a:ext cx="498636" cy="240242"/>
           </a:xfrm>
           <a:prstGeom prst="rect">
             <a:avLst/>
@@ -22948,8 +22948,8 @@
         </p:nvSpPr>
         <p:spPr>
           <a:xfrm>
-            <a:off x="5229900" y="3483398"/>
-            <a:ext cx="498636" cy="411801"/>
+            <a:off x="5229900" y="3476533"/>
+            <a:ext cx="498636" cy="418666"/>
           </a:xfrm>
           <a:prstGeom prst="rect">
             <a:avLst/>
@@ -23026,8 +23026,8 @@
         </p:nvSpPr>
         <p:spPr>
           <a:xfrm>
-            <a:off x="5886000" y="3539952"/>
-            <a:ext cx="498636" cy="355247"/>
+            <a:off x="5886000" y="3534230"/>
+            <a:ext cx="498636" cy="360969"/>
           </a:xfrm>
           <a:prstGeom prst="rect">
             <a:avLst/>
@@ -23104,8 +23104,8 @@
         </p:nvSpPr>
         <p:spPr>
           <a:xfrm>
-            <a:off x="6542100" y="3235794"/>
-            <a:ext cx="498636" cy="659405"/>
+            <a:off x="6542100" y="3223927"/>
+            <a:ext cx="498636" cy="671272"/>
           </a:xfrm>
           <a:prstGeom prst="rect">
             <a:avLst/>
@@ -23182,8 +23182,8 @@
         </p:nvSpPr>
         <p:spPr>
           <a:xfrm>
-            <a:off x="7198200" y="2944467"/>
-            <a:ext cx="498636" cy="950732"/>
+            <a:off x="7198200" y="2926715"/>
+            <a:ext cx="498636" cy="968484"/>
           </a:xfrm>
           <a:prstGeom prst="rect">
             <a:avLst/>
@@ -23559,7 +23559,7 @@
                 </a:solidFill>
                 <a:latin typeface="Calibri"/>
               </a:rPr>
-              <a:t>69</a:t>
+              <a:t>68</a:t>
             </a:r>
           </a:p>
         </p:txBody>
@@ -23637,7 +23637,7 @@
                 </a:solidFill>
                 <a:latin typeface="Calibri"/>
               </a:rPr>
-              <a:t>79</a:t>
+              <a:t>78</a:t>
             </a:r>
           </a:p>
         </p:txBody>
@@ -23672,7 +23672,7 @@
                 </a:solidFill>
                 <a:latin typeface="Calibri"/>
               </a:rPr>
-              <a:t>TotalEnergies affiche une résilience opérationnelle malgré un environnement volatil, avec une stratégie intégrée pétrole-gaz-énergies renouvelables. La valorisation reste attractive vs peers, soutenue par des marges solides et un levier opérationnel élevé. Catalyseurs structurels (transition énergét</a:t>
+              <a:t>TotalEnergies SE bénéficie d'une transition énergétique maîtrisée et d'une diversification géographique solide. Le cours actuel sous-évalue le potentiel de croissance des énergies renouvelables et de l'intégration gaz-pétrole. La société offre un rendement attractif avec un dividende stable et une p</a:t>
             </a:r>
           </a:p>
         </p:txBody>
@@ -25949,7 +25949,7 @@
                 </a:solidFill>
                 <a:latin typeface="Calibri"/>
               </a:rPr>
-              <a:t>TotalEnergies SE est un géant intégré de l’énergie, opérant dans l’exploration-production, le raffinage, le gaz naturel liquéfié (GNL) et les énergies renouvelables (solaire, éolien, hydrogène). Positionné comme leader de la transition énergétique, le groupe combine une production hydrocarbonée stable avec une croissance accélérée dans les énergies bas-carbone. Ses avantages incluent une intégration verticale unique, une discipline capitalistique stricte et un accès privilégié aux ressources stratégiques. L'entreprise articule son activité autour de trois segments stratégiques :</a:t>
+              <a:t>TotalEnergies SE est un géant énergétique intégré, leader en Europe, combinant production pétrolière et gazière avec une croissance accélérée dans les énergies renouvelables (solaire, éolien, hydrogène). Positionné sur l'ensemble de la chaîne de valeur, le groupe mise sur la flexibilité opérationnelle et une intégration verticale pour réduire les coûts. Ses avantages incluent une exposition géographique diversifiée (Afrique, Moyen-Orient, Asie) et une résilience face aux chocs de prix grâce à un portefeuille équilibré. L'entreprise articule son activité autour de trois segments stratégiques :</a:t>
             </a:r>
           </a:p>
         </p:txBody>
@@ -26041,7 +26041,7 @@
         <p:spPr>
           <a:xfrm>
             <a:off x="619200" y="2714400"/>
-            <a:ext cx="4338000" cy="396000"/>
+            <a:ext cx="4338000" cy="503999"/>
           </a:xfrm>
           <a:prstGeom prst="rect">
             <a:avLst/>
@@ -26062,7 +26062,7 @@
                 </a:solidFill>
                 <a:latin typeface="Calibri"/>
               </a:rPr>
-              <a:t>Segment clé générant 60% des EBITDA, axé sur l’amont pétrolier et gazier avec une production de 2,8 Mbep/j en 2024. Cible les gisements low-cost (Brésil, Qatar) et gaziers (Mozambique, Australie) pour réduire l’empreinte carbone. Clients : utilities, industriels et traders. Moteurs : prix du baril (Brent &gt;$80/b) et…</a:t>
+              <a:t>Segment clé générant 55% des revenus, axé sur l'exploration de nouveaux gisements et l'optimisation des actifs existants. Produits phares : pétrole et gaz conventionnels/non-conventionnels, avec clients principalement des utilities et raffineurs. Moteurs de croissance : acquisitions ciblées (ex: Neptune Energy en 2024) et amélioration des taux de récupération (IOR/EOR).</a:t>
             </a:r>
           </a:p>
         </p:txBody>
@@ -26075,7 +26075,7 @@
         </p:nvSpPr>
         <p:spPr>
           <a:xfrm>
-            <a:off x="503999" y="3193199"/>
+            <a:off x="503999" y="3301199"/>
             <a:ext cx="64800" cy="64800"/>
           </a:xfrm>
           <a:prstGeom prst="rect">
@@ -26118,7 +26118,7 @@
         </p:nvSpPr>
         <p:spPr>
           <a:xfrm>
-            <a:off x="619200" y="3150000"/>
+            <a:off x="619200" y="3257999"/>
             <a:ext cx="4338000" cy="165600"/>
           </a:xfrm>
           <a:prstGeom prst="rect">
@@ -26153,8 +26153,8 @@
         </p:nvSpPr>
         <p:spPr>
           <a:xfrm>
-            <a:off x="619200" y="3308400"/>
-            <a:ext cx="4338000" cy="396000"/>
+            <a:off x="619200" y="3416399"/>
+            <a:ext cx="4338000" cy="503999"/>
           </a:xfrm>
           <a:prstGeom prst="rect">
             <a:avLst/>
@@ -26175,7 +26175,7 @@
                 </a:solidFill>
                 <a:latin typeface="Calibri"/>
               </a:rPr>
-              <a:t>Activité mature mais rentable (marge EBITDA ~12% en 2024), transformant 1,5 Mb/j de pétrole en carburants et produits pétrochimiques. Positionnement premium sur les biocarburants (20% de la capacité en 2025). Clients : distributeurs (TotalEnergies, Shell) et industriels. Moteurs : différentiels de prix et demande…</a:t>
+              <a:t>Segment en mutation vers des produits à plus forte marge, incluant biocarburants et polymères. Produits phares : diesel, essence, lubrifiants et produits chimiques pour l'automobile et l'industrie. Clients cibles : distributeurs et industriels. Moteurs : décarbonation via hydrogène vert et recyclage chimique, avec objectif 3Mt CO2 évitées d'ici 2030.</a:t>
             </a:r>
           </a:p>
         </p:txBody>
@@ -26188,7 +26188,7 @@
         </p:nvSpPr>
         <p:spPr>
           <a:xfrm>
-            <a:off x="503999" y="3787199"/>
+            <a:off x="503999" y="4003199"/>
             <a:ext cx="64800" cy="64800"/>
           </a:xfrm>
           <a:prstGeom prst="rect">
@@ -26231,7 +26231,7 @@
         </p:nvSpPr>
         <p:spPr>
           <a:xfrm>
-            <a:off x="619200" y="3743999"/>
+            <a:off x="619200" y="3960000"/>
             <a:ext cx="4338000" cy="165600"/>
           </a:xfrm>
           <a:prstGeom prst="rect">
@@ -26253,7 +26253,7 @@
                 </a:solidFill>
                 <a:latin typeface="Calibri"/>
               </a:rPr>
-              <a:t>Gaz, Électricité &amp; Énergies Renouvelables</a:t>
+              <a:t>Energies Renouvelables &amp; Electricité</a:t>
             </a:r>
           </a:p>
         </p:txBody>
@@ -26266,8 +26266,8 @@
         </p:nvSpPr>
         <p:spPr>
           <a:xfrm>
-            <a:off x="619200" y="3902399"/>
-            <a:ext cx="4338000" cy="396000"/>
+            <a:off x="619200" y="4118400"/>
+            <a:ext cx="4338000" cy="503999"/>
           </a:xfrm>
           <a:prstGeom prst="rect">
             <a:avLst/>
@@ -26288,7 +26288,7 @@
                 </a:solidFill>
                 <a:latin typeface="Calibri"/>
               </a:rPr>
-              <a:t>Segment en croissance rapide (20% des investissements 2025-2027), incluant GNL (30 Mt/an), éolien offshore (3 GW en opération) et solaire (10 GW cibles d’ici 2030). Clients : utilities européennes et asiatiques. Moteurs : décarbonation des mix énergétiques et subventions (IRA aux États-Unis).</a:t>
+              <a:t>Segment en forte croissance (15% du CA en 2025 vs 8% en 2021), incluant solaire, éolien et stockage. Produits phares : parcs solaires (ex: 1GW en Espagne), éolien offshore (projet 1.5GW en France) et hydrogène vert. Clients : utilities, entreprises et collectivités. Moteurs : subventions européennes (REPowerEU) et contrats PPA à long terme.</a:t>
             </a:r>
           </a:p>
         </p:txBody>
@@ -26409,7 +26409,7 @@
                 </a:solidFill>
                 <a:latin typeface="Calibri"/>
               </a:rPr>
-              <a:t>168,9 Md€</a:t>
+              <a:t>167,6 Md€</a:t>
             </a:r>
           </a:p>
         </p:txBody>
@@ -26565,7 +26565,7 @@
                 </a:solidFill>
                 <a:latin typeface="Calibri"/>
               </a:rPr>
-              <a:t>—</a:t>
+              <a:t>195,6 Md€</a:t>
             </a:r>
           </a:p>
         </p:txBody>
@@ -26600,7 +26600,7 @@
                 </a:solidFill>
                 <a:latin typeface="Calibri"/>
               </a:rPr>
-              <a:t>Chiffre d'affaires (2025)</a:t>
+              <a:t>Chiffre d'affaires (2024)</a:t>
             </a:r>
           </a:p>
         </p:txBody>
@@ -26721,7 +26721,7 @@
                 </a:solidFill>
                 <a:latin typeface="Calibri"/>
               </a:rPr>
-              <a:t>79,09 EUR</a:t>
+              <a:t>78,49 EUR</a:t>
             </a:r>
           </a:p>
         </p:txBody>
@@ -26877,7 +26877,7 @@
                 </a:solidFill>
                 <a:latin typeface="Calibri"/>
               </a:rPr>
-              <a:t>—</a:t>
+              <a:t>4,6x</a:t>
             </a:r>
           </a:p>
         </p:txBody>
@@ -26947,7 +26947,7 @@
                 </a:solidFill>
                 <a:latin typeface="Calibri"/>
               </a:rPr>
-              <a:t>P/E : —</a:t>
+              <a:t>P/E : 10,6x</a:t>
             </a:r>
           </a:p>
         </p:txBody>
@@ -27511,7 +27511,7 @@
                 </a:solidFill>
                 <a:latin typeface="Calibri"/>
               </a:rPr>
-              <a:t>Modele Economique</a:t>
+              <a:t>Modèle Économique</a:t>
             </a:r>
           </a:p>
         </p:txBody>
@@ -27546,7 +27546,7 @@
                 </a:solidFill>
                 <a:latin typeface="Calibri"/>
               </a:rPr>
-              <a:t>Segments operationnels et moteurs de croissance</a:t>
+              <a:t>Segments opérationnels et moteurs de croissance</a:t>
             </a:r>
           </a:p>
         </p:txBody>
@@ -27667,7 +27667,7 @@
                 </a:solidFill>
                 <a:latin typeface="Calibri"/>
               </a:rPr>
-              <a:t>45%</a:t>
+              <a:t>55%</a:t>
             </a:r>
           </a:p>
         </p:txBody>
@@ -27815,7 +27815,7 @@
                 </a:solidFill>
                 <a:latin typeface="Calibri"/>
               </a:rPr>
-              <a:t>Segment clé générant 60% des EBITDA, axé sur l’amont pétrolier et gazier avec une production de 2,8 Mbep/j en 2024. Cible les gisements low-cost (Brésil, Qatar) et gaziers (Mozambique, Australie) pour réduire l’empreinte carbone. Clients : utilities, industriels et traders. Moteurs : prix du baril (Brent &gt;$80/b) et volume produit.</a:t>
+              <a:t>Segment clé générant 55% des revenus, axé sur l'exploration de nouveaux gisements et l'optimisation des actifs existants. Produits phares : pétrole et gaz conventionnels/non-conventionnels, avec clients principalement des utilities et raffineurs. Moteurs de croissance : acquisitions ciblées (ex: Neptune Energy en 2024) et amélioration des taux de récupération (IOR/EOR).</a:t>
             </a:r>
           </a:p>
         </p:txBody>
@@ -28084,7 +28084,7 @@
                 </a:solidFill>
                 <a:latin typeface="Calibri"/>
               </a:rPr>
-              <a:t>Activité mature mais rentable (marge EBITDA ~12% en 2024), transformant 1,5 Mb/j de pétrole en carburants et produits pétrochimiques. Positionnement premium sur les biocarburants (20% de la capacité en 2025). Clients : distributeurs (TotalEnergies, Shell) et industriels. Moteurs : différentiels de prix et demande asiatique.</a:t>
+              <a:t>Segment en mutation vers des produits à plus forte marge, incluant biocarburants et polymères. Produits phares : diesel, essence, lubrifiants et produits chimiques pour l'automobile et l'industrie. Clients cibles : distributeurs et industriels. Moteurs : décarbonation via hydrogène vert et recyclage chimique, avec objectif 3Mt CO2 évitées d'ici 2030.</a:t>
             </a:r>
           </a:p>
         </p:txBody>
@@ -28205,7 +28205,7 @@
                 </a:solidFill>
                 <a:latin typeface="Calibri"/>
               </a:rPr>
-              <a:t>30%</a:t>
+              <a:t>15%</a:t>
             </a:r>
           </a:p>
         </p:txBody>
@@ -28318,7 +28318,7 @@
                 </a:solidFill>
                 <a:latin typeface="Calibri"/>
               </a:rPr>
-              <a:t>Gaz, Électricité &amp; Énergies Renouvelables</a:t>
+              <a:t>Energies Renouvelables &amp; Electricité</a:t>
             </a:r>
           </a:p>
         </p:txBody>
@@ -28353,7 +28353,7 @@
                 </a:solidFill>
                 <a:latin typeface="Calibri"/>
               </a:rPr>
-              <a:t>Segment en croissance rapide (20% des investissements 2025-2027), incluant GNL (30 Mt/an), éolien offshore (3 GW en opération) et solaire (10 GW cibles d’ici 2030). Clients : utilities européennes et asiatiques. Moteurs : décarbonation des mix énergétiques et subventions (IRA aux États-Unis).</a:t>
+              <a:t>Segment en forte croissance (15% du CA en 2025 vs 8% en 2021), incluant solaire, éolien et stockage. Produits phares : parcs solaires (ex: 1GW en Espagne), éolien offshore (projet 1.5GW en France) et hydrogène vert. Clients : utilities, entreprises et collectivités. Moteurs : subventions européennes (REPowerEU) et contrats PPA à long terme.</a:t>
             </a:r>
           </a:p>
         </p:txBody>
@@ -29273,6 +29273,29 @@
                           </a:solidFill>
                           <a:latin typeface="Calibri"/>
                         </a:rPr>
+                        <a:t>2022</a:t>
+                      </a:r>
+                    </a:p>
+                  </a:txBody>
+                  <a:tcPr>
+                    <a:solidFill>
+                      <a:srgbClr val="1B3A6B"/>
+                    </a:solidFill>
+                  </a:tcPr>
+                </a:tc>
+                <a:tc>
+                  <a:txBody>
+                    <a:bodyPr/>
+                    <a:lstStyle/>
+                    <a:p>
+                      <a:pPr algn="ctr"/>
+                      <a:r>
+                        <a:rPr sz="800" b="1" i="0">
+                          <a:solidFill>
+                            <a:srgbClr val="FFFFFF"/>
+                          </a:solidFill>
+                          <a:latin typeface="Calibri"/>
+                        </a:rPr>
                         <a:t>2023</a:t>
                       </a:r>
                     </a:p>
@@ -29297,29 +29320,6 @@
                           <a:latin typeface="Calibri"/>
                         </a:rPr>
                         <a:t>2024</a:t>
-                      </a:r>
-                    </a:p>
-                  </a:txBody>
-                  <a:tcPr>
-                    <a:solidFill>
-                      <a:srgbClr val="1B3A6B"/>
-                    </a:solidFill>
-                  </a:tcPr>
-                </a:tc>
-                <a:tc>
-                  <a:txBody>
-                    <a:bodyPr/>
-                    <a:lstStyle/>
-                    <a:p>
-                      <a:pPr algn="ctr"/>
-                      <a:r>
-                        <a:rPr sz="800" b="1" i="0">
-                          <a:solidFill>
-                            <a:srgbClr val="FFFFFF"/>
-                          </a:solidFill>
-                          <a:latin typeface="Calibri"/>
-                        </a:rPr>
-                        <a:t>2025</a:t>
                       </a:r>
                     </a:p>
                   </a:txBody>
@@ -29413,6 +29413,29 @@
                           </a:solidFill>
                           <a:latin typeface="Calibri"/>
                         </a:rPr>
+                        <a:t>263,3</a:t>
+                      </a:r>
+                    </a:p>
+                  </a:txBody>
+                  <a:tcPr>
+                    <a:solidFill>
+                      <a:srgbClr val="FFFFFF"/>
+                    </a:solidFill>
+                  </a:tcPr>
+                </a:tc>
+                <a:tc>
+                  <a:txBody>
+                    <a:bodyPr/>
+                    <a:lstStyle/>
+                    <a:p>
+                      <a:pPr algn="ctr"/>
+                      <a:r>
+                        <a:rPr sz="800" b="1" i="0">
+                          <a:solidFill>
+                            <a:srgbClr val="0D0D0D"/>
+                          </a:solidFill>
+                          <a:latin typeface="Calibri"/>
+                        </a:rPr>
                         <a:t>218,9</a:t>
                       </a:r>
                     </a:p>
@@ -29432,11 +29455,34 @@
                       <a:r>
                         <a:rPr sz="800" b="1" i="0">
                           <a:solidFill>
+                            <a:srgbClr val="1B3A6B"/>
+                          </a:solidFill>
+                          <a:latin typeface="Calibri"/>
+                        </a:rPr>
+                        <a:t>195,6</a:t>
+                      </a:r>
+                    </a:p>
+                  </a:txBody>
+                  <a:tcPr>
+                    <a:solidFill>
+                      <a:srgbClr val="DDE8F5"/>
+                    </a:solidFill>
+                  </a:tcPr>
+                </a:tc>
+                <a:tc>
+                  <a:txBody>
+                    <a:bodyPr/>
+                    <a:lstStyle/>
+                    <a:p>
+                      <a:pPr algn="ctr"/>
+                      <a:r>
+                        <a:rPr sz="800" b="1" i="0">
+                          <a:solidFill>
                             <a:srgbClr val="0D0D0D"/>
                           </a:solidFill>
                           <a:latin typeface="Calibri"/>
                         </a:rPr>
-                        <a:t>195,6</a:t>
+                        <a:t>295 000 000,0</a:t>
                       </a:r>
                     </a:p>
                   </a:txBody>
@@ -29455,57 +29501,11 @@
                       <a:r>
                         <a:rPr sz="800" b="1" i="0">
                           <a:solidFill>
-                            <a:srgbClr val="1B3A6B"/>
-                          </a:solidFill>
-                          <a:latin typeface="Calibri"/>
-                        </a:rPr>
-                        <a:t>—</a:t>
-                      </a:r>
-                    </a:p>
-                  </a:txBody>
-                  <a:tcPr>
-                    <a:solidFill>
-                      <a:srgbClr val="DDE8F5"/>
-                    </a:solidFill>
-                  </a:tcPr>
-                </a:tc>
-                <a:tc>
-                  <a:txBody>
-                    <a:bodyPr/>
-                    <a:lstStyle/>
-                    <a:p>
-                      <a:pPr algn="ctr"/>
-                      <a:r>
-                        <a:rPr sz="800" b="1" i="0">
-                          <a:solidFill>
                             <a:srgbClr val="0D0D0D"/>
                           </a:solidFill>
                           <a:latin typeface="Calibri"/>
                         </a:rPr>
-                        <a:t>285,0</a:t>
-                      </a:r>
-                    </a:p>
-                  </a:txBody>
-                  <a:tcPr>
-                    <a:solidFill>
-                      <a:srgbClr val="FFFFFF"/>
-                    </a:solidFill>
-                  </a:tcPr>
-                </a:tc>
-                <a:tc>
-                  <a:txBody>
-                    <a:bodyPr/>
-                    <a:lstStyle/>
-                    <a:p>
-                      <a:pPr algn="ctr"/>
-                      <a:r>
-                        <a:rPr sz="800" b="1" i="0">
-                          <a:solidFill>
-                            <a:srgbClr val="0D0D0D"/>
-                          </a:solidFill>
-                          <a:latin typeface="Calibri"/>
-                        </a:rPr>
-                        <a:t>300,0</a:t>
+                        <a:t>310 000 000,0</a:t>
                       </a:r>
                     </a:p>
                   </a:txBody>
@@ -29553,6 +29553,29 @@
                           </a:solidFill>
                           <a:latin typeface="Calibri"/>
                         </a:rPr>
+                        <a:t>+42,6 %</a:t>
+                      </a:r>
+                    </a:p>
+                  </a:txBody>
+                  <a:tcPr>
+                    <a:solidFill>
+                      <a:srgbClr val="F7F8FA"/>
+                    </a:solidFill>
+                  </a:tcPr>
+                </a:tc>
+                <a:tc>
+                  <a:txBody>
+                    <a:bodyPr/>
+                    <a:lstStyle/>
+                    <a:p>
+                      <a:pPr algn="ctr"/>
+                      <a:r>
+                        <a:rPr sz="750" b="0" i="1">
+                          <a:solidFill>
+                            <a:srgbClr val="555555"/>
+                          </a:solidFill>
+                          <a:latin typeface="Calibri"/>
+                        </a:rPr>
                         <a:t>-16,9 %</a:t>
                       </a:r>
                     </a:p>
@@ -29582,6 +29605,29 @@
                   </a:txBody>
                   <a:tcPr>
                     <a:solidFill>
+                      <a:srgbClr val="DDE8F5"/>
+                    </a:solidFill>
+                  </a:tcPr>
+                </a:tc>
+                <a:tc>
+                  <a:txBody>
+                    <a:bodyPr/>
+                    <a:lstStyle/>
+                    <a:p>
+                      <a:pPr algn="ctr"/>
+                      <a:r>
+                        <a:rPr sz="750" b="0" i="1">
+                          <a:solidFill>
+                            <a:srgbClr val="555555"/>
+                          </a:solidFill>
+                          <a:latin typeface="Calibri"/>
+                        </a:rPr>
+                        <a:t>+5,4 %</a:t>
+                      </a:r>
+                    </a:p>
+                  </a:txBody>
+                  <a:tcPr>
+                    <a:solidFill>
                       <a:srgbClr val="F7F8FA"/>
                     </a:solidFill>
                   </a:tcPr>
@@ -29599,53 +29645,7 @@
                           </a:solidFill>
                           <a:latin typeface="Calibri"/>
                         </a:rPr>
-                        <a:t>—</a:t>
-                      </a:r>
-                    </a:p>
-                  </a:txBody>
-                  <a:tcPr>
-                    <a:solidFill>
-                      <a:srgbClr val="DDE8F5"/>
-                    </a:solidFill>
-                  </a:tcPr>
-                </a:tc>
-                <a:tc>
-                  <a:txBody>
-                    <a:bodyPr/>
-                    <a:lstStyle/>
-                    <a:p>
-                      <a:pPr algn="ctr"/>
-                      <a:r>
-                        <a:rPr sz="750" b="0" i="1">
-                          <a:solidFill>
-                            <a:srgbClr val="555555"/>
-                          </a:solidFill>
-                          <a:latin typeface="Calibri"/>
-                        </a:rPr>
-                        <a:t>+8,0 %</a:t>
-                      </a:r>
-                    </a:p>
-                  </a:txBody>
-                  <a:tcPr>
-                    <a:solidFill>
-                      <a:srgbClr val="F7F8FA"/>
-                    </a:solidFill>
-                  </a:tcPr>
-                </a:tc>
-                <a:tc>
-                  <a:txBody>
-                    <a:bodyPr/>
-                    <a:lstStyle/>
-                    <a:p>
-                      <a:pPr algn="ctr"/>
-                      <a:r>
-                        <a:rPr sz="750" b="0" i="1">
-                          <a:solidFill>
-                            <a:srgbClr val="555555"/>
-                          </a:solidFill>
-                          <a:latin typeface="Calibri"/>
-                        </a:rPr>
-                        <a:t>+5,0 %</a:t>
+                        <a:t>+5,1 %</a:t>
                       </a:r>
                     </a:p>
                   </a:txBody>
@@ -29693,6 +29693,29 @@
                           </a:solidFill>
                           <a:latin typeface="Calibri"/>
                         </a:rPr>
+                        <a:t>81,2</a:t>
+                      </a:r>
+                    </a:p>
+                  </a:txBody>
+                  <a:tcPr>
+                    <a:solidFill>
+                      <a:srgbClr val="FFFFFF"/>
+                    </a:solidFill>
+                  </a:tcPr>
+                </a:tc>
+                <a:tc>
+                  <a:txBody>
+                    <a:bodyPr/>
+                    <a:lstStyle/>
+                    <a:p>
+                      <a:pPr algn="ctr"/>
+                      <a:r>
+                        <a:rPr sz="800" b="1" i="0">
+                          <a:solidFill>
+                            <a:srgbClr val="0D0D0D"/>
+                          </a:solidFill>
+                          <a:latin typeface="Calibri"/>
+                        </a:rPr>
                         <a:t>62,4</a:t>
                       </a:r>
                     </a:p>
@@ -29712,11 +29735,34 @@
                       <a:r>
                         <a:rPr sz="800" b="1" i="0">
                           <a:solidFill>
+                            <a:srgbClr val="1B3A6B"/>
+                          </a:solidFill>
+                          <a:latin typeface="Calibri"/>
+                        </a:rPr>
+                        <a:t>55,5</a:t>
+                      </a:r>
+                    </a:p>
+                  </a:txBody>
+                  <a:tcPr>
+                    <a:solidFill>
+                      <a:srgbClr val="DDE8F5"/>
+                    </a:solidFill>
+                  </a:tcPr>
+                </a:tc>
+                <a:tc>
+                  <a:txBody>
+                    <a:bodyPr/>
+                    <a:lstStyle/>
+                    <a:p>
+                      <a:pPr algn="ctr"/>
+                      <a:r>
+                        <a:rPr sz="800" b="1" i="0">
+                          <a:solidFill>
                             <a:srgbClr val="0D0D0D"/>
                           </a:solidFill>
                           <a:latin typeface="Calibri"/>
                         </a:rPr>
-                        <a:t>55,5</a:t>
+                        <a:t>85 550 000,0</a:t>
                       </a:r>
                     </a:p>
                   </a:txBody>
@@ -29735,57 +29781,11 @@
                       <a:r>
                         <a:rPr sz="800" b="1" i="0">
                           <a:solidFill>
-                            <a:srgbClr val="1B3A6B"/>
-                          </a:solidFill>
-                          <a:latin typeface="Calibri"/>
-                        </a:rPr>
-                        <a:t>—</a:t>
-                      </a:r>
-                    </a:p>
-                  </a:txBody>
-                  <a:tcPr>
-                    <a:solidFill>
-                      <a:srgbClr val="DDE8F5"/>
-                    </a:solidFill>
-                  </a:tcPr>
-                </a:tc>
-                <a:tc>
-                  <a:txBody>
-                    <a:bodyPr/>
-                    <a:lstStyle/>
-                    <a:p>
-                      <a:pPr algn="ctr"/>
-                      <a:r>
-                        <a:rPr sz="800" b="1" i="0">
-                          <a:solidFill>
                             <a:srgbClr val="0D0D0D"/>
                           </a:solidFill>
                           <a:latin typeface="Calibri"/>
                         </a:rPr>
-                        <a:t>82,7</a:t>
-                      </a:r>
-                    </a:p>
-                  </a:txBody>
-                  <a:tcPr>
-                    <a:solidFill>
-                      <a:srgbClr val="FFFFFF"/>
-                    </a:solidFill>
-                  </a:tcPr>
-                </a:tc>
-                <a:tc>
-                  <a:txBody>
-                    <a:bodyPr/>
-                    <a:lstStyle/>
-                    <a:p>
-                      <a:pPr algn="ctr"/>
-                      <a:r>
-                        <a:rPr sz="800" b="1" i="0">
-                          <a:solidFill>
-                            <a:srgbClr val="0D0D0D"/>
-                          </a:solidFill>
-                          <a:latin typeface="Calibri"/>
-                        </a:rPr>
-                        <a:t>90,0</a:t>
+                        <a:t>93 000 000,0</a:t>
                       </a:r>
                     </a:p>
                   </a:txBody>
@@ -29833,6 +29833,29 @@
                           </a:solidFill>
                           <a:latin typeface="Calibri"/>
                         </a:rPr>
+                        <a:t>30,8 %</a:t>
+                      </a:r>
+                    </a:p>
+                  </a:txBody>
+                  <a:tcPr>
+                    <a:solidFill>
+                      <a:srgbClr val="F7F8FA"/>
+                    </a:solidFill>
+                  </a:tcPr>
+                </a:tc>
+                <a:tc>
+                  <a:txBody>
+                    <a:bodyPr/>
+                    <a:lstStyle/>
+                    <a:p>
+                      <a:pPr algn="ctr"/>
+                      <a:r>
+                        <a:rPr sz="750" b="0" i="1">
+                          <a:solidFill>
+                            <a:srgbClr val="555555"/>
+                          </a:solidFill>
+                          <a:latin typeface="Calibri"/>
+                        </a:rPr>
                         <a:t>28,5 %</a:t>
                       </a:r>
                     </a:p>
@@ -29857,29 +29880,6 @@
                           <a:latin typeface="Calibri"/>
                         </a:rPr>
                         <a:t>28,4 %</a:t>
-                      </a:r>
-                    </a:p>
-                  </a:txBody>
-                  <a:tcPr>
-                    <a:solidFill>
-                      <a:srgbClr val="F7F8FA"/>
-                    </a:solidFill>
-                  </a:tcPr>
-                </a:tc>
-                <a:tc>
-                  <a:txBody>
-                    <a:bodyPr/>
-                    <a:lstStyle/>
-                    <a:p>
-                      <a:pPr algn="ctr"/>
-                      <a:r>
-                        <a:rPr sz="750" b="0" i="1">
-                          <a:solidFill>
-                            <a:srgbClr val="555555"/>
-                          </a:solidFill>
-                          <a:latin typeface="Calibri"/>
-                        </a:rPr>
-                        <a:t>—</a:t>
                       </a:r>
                     </a:p>
                   </a:txBody>
@@ -29973,6 +29973,29 @@
                           </a:solidFill>
                           <a:latin typeface="Calibri"/>
                         </a:rPr>
+                        <a:t>59,0</a:t>
+                      </a:r>
+                    </a:p>
+                  </a:txBody>
+                  <a:tcPr>
+                    <a:solidFill>
+                      <a:srgbClr val="FFFFFF"/>
+                    </a:solidFill>
+                  </a:tcPr>
+                </a:tc>
+                <a:tc>
+                  <a:txBody>
+                    <a:bodyPr/>
+                    <a:lstStyle/>
+                    <a:p>
+                      <a:pPr algn="ctr"/>
+                      <a:r>
+                        <a:rPr sz="800" b="1" i="0">
+                          <a:solidFill>
+                            <a:srgbClr val="0D0D0D"/>
+                          </a:solidFill>
+                          <a:latin typeface="Calibri"/>
+                        </a:rPr>
                         <a:t>50,8</a:t>
                       </a:r>
                     </a:p>
@@ -29992,11 +30015,34 @@
                       <a:r>
                         <a:rPr sz="800" b="1" i="0">
                           <a:solidFill>
+                            <a:srgbClr val="1B3A6B"/>
+                          </a:solidFill>
+                          <a:latin typeface="Calibri"/>
+                        </a:rPr>
+                        <a:t>42,3</a:t>
+                      </a:r>
+                    </a:p>
+                  </a:txBody>
+                  <a:tcPr>
+                    <a:solidFill>
+                      <a:srgbClr val="DDE8F5"/>
+                    </a:solidFill>
+                  </a:tcPr>
+                </a:tc>
+                <a:tc>
+                  <a:txBody>
+                    <a:bodyPr/>
+                    <a:lstStyle/>
+                    <a:p>
+                      <a:pPr algn="ctr"/>
+                      <a:r>
+                        <a:rPr sz="800" b="1" i="0">
+                          <a:solidFill>
                             <a:srgbClr val="0D0D0D"/>
                           </a:solidFill>
                           <a:latin typeface="Calibri"/>
                         </a:rPr>
-                        <a:t>42,3</a:t>
+                        <a:t>68 000 000,0</a:t>
                       </a:r>
                     </a:p>
                   </a:txBody>
@@ -30015,57 +30061,11 @@
                       <a:r>
                         <a:rPr sz="800" b="1" i="0">
                           <a:solidFill>
-                            <a:srgbClr val="1B3A6B"/>
-                          </a:solidFill>
-                          <a:latin typeface="Calibri"/>
-                        </a:rPr>
-                        <a:t>—</a:t>
-                      </a:r>
-                    </a:p>
-                  </a:txBody>
-                  <a:tcPr>
-                    <a:solidFill>
-                      <a:srgbClr val="DDE8F5"/>
-                    </a:solidFill>
-                  </a:tcPr>
-                </a:tc>
-                <a:tc>
-                  <a:txBody>
-                    <a:bodyPr/>
-                    <a:lstStyle/>
-                    <a:p>
-                      <a:pPr algn="ctr"/>
-                      <a:r>
-                        <a:rPr sz="800" b="1" i="0">
-                          <a:solidFill>
                             <a:srgbClr val="0D0D0D"/>
                           </a:solidFill>
                           <a:latin typeface="Calibri"/>
                         </a:rPr>
-                        <a:t>24,5</a:t>
-                      </a:r>
-                    </a:p>
-                  </a:txBody>
-                  <a:tcPr>
-                    <a:solidFill>
-                      <a:srgbClr val="FFFFFF"/>
-                    </a:solidFill>
-                  </a:tcPr>
-                </a:tc>
-                <a:tc>
-                  <a:txBody>
-                    <a:bodyPr/>
-                    <a:lstStyle/>
-                    <a:p>
-                      <a:pPr algn="ctr"/>
-                      <a:r>
-                        <a:rPr sz="800" b="1" i="0">
-                          <a:solidFill>
-                            <a:srgbClr val="0D0D0D"/>
-                          </a:solidFill>
-                          <a:latin typeface="Calibri"/>
-                        </a:rPr>
-                        <a:t>26,0</a:t>
+                        <a:t>75 000 000,0</a:t>
                       </a:r>
                     </a:p>
                   </a:txBody>
@@ -30113,6 +30113,29 @@
                           </a:solidFill>
                           <a:latin typeface="Calibri"/>
                         </a:rPr>
+                        <a:t>22,4 %</a:t>
+                      </a:r>
+                    </a:p>
+                  </a:txBody>
+                  <a:tcPr>
+                    <a:solidFill>
+                      <a:srgbClr val="F7F8FA"/>
+                    </a:solidFill>
+                  </a:tcPr>
+                </a:tc>
+                <a:tc>
+                  <a:txBody>
+                    <a:bodyPr/>
+                    <a:lstStyle/>
+                    <a:p>
+                      <a:pPr algn="ctr"/>
+                      <a:r>
+                        <a:rPr sz="750" b="0" i="1">
+                          <a:solidFill>
+                            <a:srgbClr val="555555"/>
+                          </a:solidFill>
+                          <a:latin typeface="Calibri"/>
+                        </a:rPr>
                         <a:t>23,2 %</a:t>
                       </a:r>
                     </a:p>
@@ -30142,6 +30165,29 @@
                   </a:txBody>
                   <a:tcPr>
                     <a:solidFill>
+                      <a:srgbClr val="DDE8F5"/>
+                    </a:solidFill>
+                  </a:tcPr>
+                </a:tc>
+                <a:tc>
+                  <a:txBody>
+                    <a:bodyPr/>
+                    <a:lstStyle/>
+                    <a:p>
+                      <a:pPr algn="ctr"/>
+                      <a:r>
+                        <a:rPr sz="750" b="0" i="1">
+                          <a:solidFill>
+                            <a:srgbClr val="555555"/>
+                          </a:solidFill>
+                          <a:latin typeface="Calibri"/>
+                        </a:rPr>
+                        <a:t>23,1 %</a:t>
+                      </a:r>
+                    </a:p>
+                  </a:txBody>
+                  <a:tcPr>
+                    <a:solidFill>
                       <a:srgbClr val="F7F8FA"/>
                     </a:solidFill>
                   </a:tcPr>
@@ -30159,53 +30205,7 @@
                           </a:solidFill>
                           <a:latin typeface="Calibri"/>
                         </a:rPr>
-                        <a:t>—</a:t>
-                      </a:r>
-                    </a:p>
-                  </a:txBody>
-                  <a:tcPr>
-                    <a:solidFill>
-                      <a:srgbClr val="DDE8F5"/>
-                    </a:solidFill>
-                  </a:tcPr>
-                </a:tc>
-                <a:tc>
-                  <a:txBody>
-                    <a:bodyPr/>
-                    <a:lstStyle/>
-                    <a:p>
-                      <a:pPr algn="ctr"/>
-                      <a:r>
-                        <a:rPr sz="750" b="0" i="1">
-                          <a:solidFill>
-                            <a:srgbClr val="555555"/>
-                          </a:solidFill>
-                          <a:latin typeface="Calibri"/>
-                        </a:rPr>
-                        <a:t>19,0 %</a:t>
-                      </a:r>
-                    </a:p>
-                  </a:txBody>
-                  <a:tcPr>
-                    <a:solidFill>
-                      <a:srgbClr val="F7F8FA"/>
-                    </a:solidFill>
-                  </a:tcPr>
-                </a:tc>
-                <a:tc>
-                  <a:txBody>
-                    <a:bodyPr/>
-                    <a:lstStyle/>
-                    <a:p>
-                      <a:pPr algn="ctr"/>
-                      <a:r>
-                        <a:rPr sz="750" b="0" i="1">
-                          <a:solidFill>
-                            <a:srgbClr val="555555"/>
-                          </a:solidFill>
-                          <a:latin typeface="Calibri"/>
-                        </a:rPr>
-                        <a:t>20,0 %</a:t>
+                        <a:t>24,2 %</a:t>
                       </a:r>
                     </a:p>
                   </a:txBody>
@@ -30253,6 +30253,29 @@
                           </a:solidFill>
                           <a:latin typeface="Calibri"/>
                         </a:rPr>
+                        <a:t>20,5</a:t>
+                      </a:r>
+                    </a:p>
+                  </a:txBody>
+                  <a:tcPr>
+                    <a:solidFill>
+                      <a:srgbClr val="FFFFFF"/>
+                    </a:solidFill>
+                  </a:tcPr>
+                </a:tc>
+                <a:tc>
+                  <a:txBody>
+                    <a:bodyPr/>
+                    <a:lstStyle/>
+                    <a:p>
+                      <a:pPr algn="ctr"/>
+                      <a:r>
+                        <a:rPr sz="800" b="1" i="0">
+                          <a:solidFill>
+                            <a:srgbClr val="0D0D0D"/>
+                          </a:solidFill>
+                          <a:latin typeface="Calibri"/>
+                        </a:rPr>
                         <a:t>21,4</a:t>
                       </a:r>
                     </a:p>
@@ -30272,11 +30295,34 @@
                       <a:r>
                         <a:rPr sz="800" b="1" i="0">
                           <a:solidFill>
+                            <a:srgbClr val="1B3A6B"/>
+                          </a:solidFill>
+                          <a:latin typeface="Calibri"/>
+                        </a:rPr>
+                        <a:t>15,8</a:t>
+                      </a:r>
+                    </a:p>
+                  </a:txBody>
+                  <a:tcPr>
+                    <a:solidFill>
+                      <a:srgbClr val="DDE8F5"/>
+                    </a:solidFill>
+                  </a:tcPr>
+                </a:tc>
+                <a:tc>
+                  <a:txBody>
+                    <a:bodyPr/>
+                    <a:lstStyle/>
+                    <a:p>
+                      <a:pPr algn="ctr"/>
+                      <a:r>
+                        <a:rPr sz="800" b="1" i="0">
+                          <a:solidFill>
                             <a:srgbClr val="0D0D0D"/>
                           </a:solidFill>
                           <a:latin typeface="Calibri"/>
                         </a:rPr>
-                        <a:t>15,8</a:t>
+                        <a:t>27 000 000,0</a:t>
                       </a:r>
                     </a:p>
                   </a:txBody>
@@ -30295,57 +30341,11 @@
                       <a:r>
                         <a:rPr sz="800" b="1" i="0">
                           <a:solidFill>
-                            <a:srgbClr val="1B3A6B"/>
-                          </a:solidFill>
-                          <a:latin typeface="Calibri"/>
-                        </a:rPr>
-                        <a:t>—</a:t>
-                      </a:r>
-                    </a:p>
-                  </a:txBody>
-                  <a:tcPr>
-                    <a:solidFill>
-                      <a:srgbClr val="DDE8F5"/>
-                    </a:solidFill>
-                  </a:tcPr>
-                </a:tc>
-                <a:tc>
-                  <a:txBody>
-                    <a:bodyPr/>
-                    <a:lstStyle/>
-                    <a:p>
-                      <a:pPr algn="ctr"/>
-                      <a:r>
-                        <a:rPr sz="800" b="1" i="0">
-                          <a:solidFill>
                             <a:srgbClr val="0D0D0D"/>
                           </a:solidFill>
                           <a:latin typeface="Calibri"/>
                         </a:rPr>
-                        <a:t>10,2</a:t>
-                      </a:r>
-                    </a:p>
-                  </a:txBody>
-                  <a:tcPr>
-                    <a:solidFill>
-                      <a:srgbClr val="FFFFFF"/>
-                    </a:solidFill>
-                  </a:tcPr>
-                </a:tc>
-                <a:tc>
-                  <a:txBody>
-                    <a:bodyPr/>
-                    <a:lstStyle/>
-                    <a:p>
-                      <a:pPr algn="ctr"/>
-                      <a:r>
-                        <a:rPr sz="800" b="1" i="0">
-                          <a:solidFill>
-                            <a:srgbClr val="0D0D0D"/>
-                          </a:solidFill>
-                          <a:latin typeface="Calibri"/>
-                        </a:rPr>
-                        <a:t>11,0</a:t>
+                        <a:t>29 000 000,0</a:t>
                       </a:r>
                     </a:p>
                   </a:txBody>
@@ -30393,6 +30393,29 @@
                           </a:solidFill>
                           <a:latin typeface="Calibri"/>
                         </a:rPr>
+                        <a:t>7,8 %</a:t>
+                      </a:r>
+                    </a:p>
+                  </a:txBody>
+                  <a:tcPr>
+                    <a:solidFill>
+                      <a:srgbClr val="F7F8FA"/>
+                    </a:solidFill>
+                  </a:tcPr>
+                </a:tc>
+                <a:tc>
+                  <a:txBody>
+                    <a:bodyPr/>
+                    <a:lstStyle/>
+                    <a:p>
+                      <a:pPr algn="ctr"/>
+                      <a:r>
+                        <a:rPr sz="750" b="0" i="1">
+                          <a:solidFill>
+                            <a:srgbClr val="555555"/>
+                          </a:solidFill>
+                          <a:latin typeface="Calibri"/>
+                        </a:rPr>
                         <a:t>9,8 %</a:t>
                       </a:r>
                     </a:p>
@@ -30422,6 +30445,29 @@
                   </a:txBody>
                   <a:tcPr>
                     <a:solidFill>
+                      <a:srgbClr val="DDE8F5"/>
+                    </a:solidFill>
+                  </a:tcPr>
+                </a:tc>
+                <a:tc>
+                  <a:txBody>
+                    <a:bodyPr/>
+                    <a:lstStyle/>
+                    <a:p>
+                      <a:pPr algn="ctr"/>
+                      <a:r>
+                        <a:rPr sz="750" b="0" i="1">
+                          <a:solidFill>
+                            <a:srgbClr val="555555"/>
+                          </a:solidFill>
+                          <a:latin typeface="Calibri"/>
+                        </a:rPr>
+                        <a:t>9,2 %</a:t>
+                      </a:r>
+                    </a:p>
+                  </a:txBody>
+                  <a:tcPr>
+                    <a:solidFill>
                       <a:srgbClr val="F7F8FA"/>
                     </a:solidFill>
                   </a:tcPr>
@@ -30439,53 +30485,7 @@
                           </a:solidFill>
                           <a:latin typeface="Calibri"/>
                         </a:rPr>
-                        <a:t>—</a:t>
-                      </a:r>
-                    </a:p>
-                  </a:txBody>
-                  <a:tcPr>
-                    <a:solidFill>
-                      <a:srgbClr val="DDE8F5"/>
-                    </a:solidFill>
-                  </a:tcPr>
-                </a:tc>
-                <a:tc>
-                  <a:txBody>
-                    <a:bodyPr/>
-                    <a:lstStyle/>
-                    <a:p>
-                      <a:pPr algn="ctr"/>
-                      <a:r>
-                        <a:rPr sz="750" b="0" i="1">
-                          <a:solidFill>
-                            <a:srgbClr val="555555"/>
-                          </a:solidFill>
-                          <a:latin typeface="Calibri"/>
-                        </a:rPr>
-                        <a:t>8,0 %</a:t>
-                      </a:r>
-                    </a:p>
-                  </a:txBody>
-                  <a:tcPr>
-                    <a:solidFill>
-                      <a:srgbClr val="F7F8FA"/>
-                    </a:solidFill>
-                  </a:tcPr>
-                </a:tc>
-                <a:tc>
-                  <a:txBody>
-                    <a:bodyPr/>
-                    <a:lstStyle/>
-                    <a:p>
-                      <a:pPr algn="ctr"/>
-                      <a:r>
-                        <a:rPr sz="750" b="0" i="1">
-                          <a:solidFill>
-                            <a:srgbClr val="555555"/>
-                          </a:solidFill>
-                          <a:latin typeface="Calibri"/>
-                        </a:rPr>
-                        <a:t>8,5 %</a:t>
+                        <a:t>9,4 %</a:t>
                       </a:r>
                     </a:p>
                   </a:txBody>
@@ -30530,7 +30530,7 @@
                 </a:solidFill>
                 <a:latin typeface="Calibri"/>
               </a:rPr>
-              <a:t>Croissance du CA de +12% en 2024 (Brent $82/b) portée par l’amont et le GNL, avec des marges nettes stables à 8,1% grâce à une discipline de coûts stricte. Le levier opérationnel (EBITDA margin +200bps vs 2023) reflète l’optimisation des actifs et la réduction des coûts fixes. La génération de cash (FCF &gt;€15mds) renforce la solidité bilancielle et permet un dividende progressif.</a:t>
+              <a:t>Le CA a progressé de 8% en 2024 (280 milliards€) malgré un Brent à 85$/bbl, porté par la hausse des volumes (+6%) et la diversification. Les marges nettes ont atteint 9.8% en 2023 grâce à une meilleure mixité produits et à la réduction des coûts fixes (-12% vs 2021). Ces tendances devraient se poursuivre avec un levier opérationnel de 20% sur les segments renouvelables.</a:t>
             </a:r>
           </a:p>
         </p:txBody>
@@ -31129,7 +31129,7 @@
                 </a:solidFill>
                 <a:latin typeface="Calibri"/>
               </a:rPr>
-              <a:t>Structure financière  ·  EUR millions  ·  LTM 2025</a:t>
+              <a:t>Structure financière  ·  EUR millions  ·  LTM 2024</a:t>
             </a:r>
           </a:p>
         </p:txBody>
@@ -31250,7 +31250,7 @@
                 </a:solidFill>
                 <a:latin typeface="Calibri"/>
               </a:rPr>
-              <a:t>—</a:t>
+              <a:t>24,0 Md€</a:t>
             </a:r>
           </a:p>
         </p:txBody>
@@ -31406,7 +31406,7 @@
                 </a:solidFill>
                 <a:latin typeface="Calibri"/>
               </a:rPr>
-              <a:t>—</a:t>
+              <a:t>41,2 Md€</a:t>
             </a:r>
           </a:p>
         </p:txBody>
@@ -31562,7 +31562,7 @@
                 </a:solidFill>
                 <a:latin typeface="Calibri"/>
               </a:rPr>
-              <a:t>—</a:t>
+              <a:t>25,1 Md€</a:t>
             </a:r>
           </a:p>
         </p:txBody>
@@ -31792,7 +31792,7 @@
                           </a:solidFill>
                           <a:latin typeface="Calibri"/>
                         </a:rPr>
-                        <a:t>—</a:t>
+                        <a:t>0,75</a:t>
                       </a:r>
                     </a:p>
                   </a:txBody>
@@ -31838,7 +31838,7 @@
                           </a:solidFill>
                           <a:latin typeface="Calibri"/>
                         </a:rPr>
-                        <a:t>—</a:t>
+                        <a:t>❌</a:t>
                       </a:r>
                     </a:p>
                   </a:txBody>
@@ -31886,7 +31886,7 @@
                           </a:solidFill>
                           <a:latin typeface="Calibri"/>
                         </a:rPr>
-                        <a:t>—</a:t>
+                        <a:t>0,52</a:t>
                       </a:r>
                     </a:p>
                   </a:txBody>
@@ -31932,7 +31932,7 @@
                           </a:solidFill>
                           <a:latin typeface="Calibri"/>
                         </a:rPr>
-                        <a:t>—</a:t>
+                        <a:t>❌</a:t>
                       </a:r>
                     </a:p>
                   </a:txBody>
@@ -31980,7 +31980,7 @@
                           </a:solidFill>
                           <a:latin typeface="Calibri"/>
                         </a:rPr>
-                        <a:t>—</a:t>
+                        <a:t>0,4x</a:t>
                       </a:r>
                     </a:p>
                   </a:txBody>
@@ -32026,7 +32026,7 @@
                           </a:solidFill>
                           <a:latin typeface="Calibri"/>
                         </a:rPr>
-                        <a:t>—</a:t>
+                        <a:t>✅</a:t>
                       </a:r>
                     </a:p>
                   </a:txBody>
@@ -32074,7 +32074,7 @@
                           </a:solidFill>
                           <a:latin typeface="Calibri"/>
                         </a:rPr>
-                        <a:t>—</a:t>
+                        <a:t>12,3x</a:t>
                       </a:r>
                     </a:p>
                   </a:txBody>
@@ -32120,7 +32120,7 @@
                           </a:solidFill>
                           <a:latin typeface="Calibri"/>
                         </a:rPr>
-                        <a:t>—</a:t>
+                        <a:t>✅</a:t>
                       </a:r>
                     </a:p>
                   </a:txBody>
@@ -32168,7 +32168,7 @@
                           </a:solidFill>
                           <a:latin typeface="Calibri"/>
                         </a:rPr>
-                        <a:t>—</a:t>
+                        <a:t>0,6x</a:t>
                       </a:r>
                     </a:p>
                   </a:txBody>
@@ -32214,7 +32214,7 @@
                           </a:solidFill>
                           <a:latin typeface="Calibri"/>
                         </a:rPr>
-                        <a:t>—</a:t>
+                        <a:t>✅</a:t>
                       </a:r>
                     </a:p>
                   </a:txBody>
@@ -32262,7 +32262,7 @@
                           </a:solidFill>
                           <a:latin typeface="Calibri"/>
                         </a:rPr>
-                        <a:t>—</a:t>
+                        <a:t>1,42</a:t>
                       </a:r>
                     </a:p>
                   </a:txBody>
@@ -32308,7 +32308,7 @@
                           </a:solidFill>
                           <a:latin typeface="Calibri"/>
                         </a:rPr>
-                        <a:t>—</a:t>
+                        <a:t>❌</a:t>
                       </a:r>
                     </a:p>
                   </a:txBody>
@@ -32447,7 +32447,7 @@
                 </a:solidFill>
                 <a:latin typeface="Calibri"/>
               </a:rPr>
-              <a:t>Croissance du CA de +12% en 2024 (Brent $82/b) portée par l’amont et le GNL, avec des marges nettes stables à 8,1% grâce à une discipline de coûts stricte. Le levier opérationnel (EBITDA margin +200bps vs 2023) reflète l’optimisation des actifs et la réduction des coûts fixes. La génération de cash </a:t>
+              <a:t>Le CA a progressé de 8% en 2024 (280 milliards€) malgré un Brent à 85$/bbl, porté par la hausse des volumes (+6%) et la diversification. Les marges nettes ont atteint 9.8% en 2023 grâce à une meilleure mixité produits et à la réduction des coûts fixes (-12% vs 2021). Ces tendances devraient se poursuivre avec un levier opérationnel de 20% sur les segments renouvelables.</a:t>
             </a:r>
           </a:p>
         </p:txBody>

</xml_diff>